<commit_message>
Reasons carousel: apply Nurassyl's edits with proofreading; interview date 28 Feb; rebuilt PPTX
Co-Authored-By: Claude Opus 5.5 <noreply@anthropic.com>
Claude-Session: https://claude.ai/code/session_01EUKBNPzc7y2DXSfnei23HU
</commit_message>
<xml_diff>
--- a/social/pptx/reasons-170m.pptx
+++ b/social/pptx/reasons-170m.pptx
@@ -2757,7 +2757,7 @@
         </p:nvSpPr>
         <p:spPr>
           <a:xfrm>
-            <a:off x="457200" y="5880100"/>
+            <a:off x="457200" y="5657850"/>
             <a:ext cx="6300216" cy="673100"/>
           </a:xfrm>
           <a:prstGeom prst="rect">
@@ -2802,7 +2802,7 @@
                 <a:ea typeface="Noto Serif Display Light" pitchFamily="34" charset="-122"/>
                 <a:cs typeface="Noto Serif Display Light" pitchFamily="34" charset="-120"/>
               </a:rPr>
-              <a:t>оказался</a:t>
+              <a:t>оказался?</a:t>
             </a:r>
             <a:endParaRPr lang="en-US" sz="4600" dirty="0"/>
           </a:p>
@@ -2816,7 +2816,7 @@
         </p:nvSpPr>
         <p:spPr>
           <a:xfrm>
-            <a:off x="457349" y="6654800"/>
+            <a:off x="457349" y="6432550"/>
             <a:ext cx="6024245" cy="666750"/>
           </a:xfrm>
           <a:prstGeom prst="rect">
@@ -2844,33 +2844,8 @@
                 <a:ea typeface="Geist" pitchFamily="34" charset="-122"/>
                 <a:cs typeface="Geist" pitchFamily="34" charset="-120"/>
               </a:rPr>
-              <a:t>Весной меня позвали в Абу-Даби на Candidate Weekend. В планах было три дня: экскурсии, пары с профессорами и тимбилдинг, где я впервые увидел своё имя на арабском.</a:t>
-            </a:r>
-            <a:endParaRPr lang="en-US" sz="1250" dirty="0"/>
-          </a:p>
-        </p:txBody>
-      </p:sp>
-      <p:sp>
-        <p:nvSpPr>
-          <p:cNvPr id="11" name="text-10"/>
-          <p:cNvSpPr txBox="1"/>
-          <p:nvPr/>
-        </p:nvSpPr>
-        <p:spPr>
-          <a:xfrm>
-            <a:off x="457349" y="7397750"/>
-            <a:ext cx="6024245" cy="222250"/>
-          </a:xfrm>
-          <a:prstGeom prst="rect">
-            <a:avLst/>
-          </a:prstGeom>
-          <a:noFill/>
-          <a:ln/>
-        </p:spPr>
-        <p:txBody>
-          <a:bodyPr wrap="square" lIns="0" tIns="0" rIns="0" bIns="0" rtlCol="0" anchor="t"/>
-          <a:lstStyle/>
-          <a:p>
+              <a:t>Весной меня позвали в Абу-Даби на Candidate Weekend. В планах было три дня: знакомство со студентами со всего мира, экскурсии по кампусу, общежитиям NYUAD и Абу-Даби, пробные лекции и </a:t>
+            </a:r>
             <a:pPr algn="l" indent="0" marL="0">
               <a:lnSpc>
                 <a:spcPts val="1750"/>
@@ -2878,15 +2853,74 @@
               <a:buNone/>
             </a:pPr>
             <a:r>
-              <a:rPr lang="en-US" sz="1250" dirty="0">
-                <a:solidFill>
-                  <a:srgbClr val="2B2A27"/>
+              <a:rPr lang="en-US" sz="1250" b="1" dirty="0">
+                <a:solidFill>
+                  <a:srgbClr val="0A0A0A"/>
                 </a:solidFill>
                 <a:latin typeface="Geist" pitchFamily="34" charset="0"/>
                 <a:ea typeface="Geist" pitchFamily="34" charset="-122"/>
                 <a:cs typeface="Geist" pitchFamily="34" charset="-120"/>
               </a:rPr>
-              <a:t>Интервью стояло на 1 марта. В ночь перед ним всё пошло не по плану.</a:t>
+              <a:t>интервью</a:t>
+            </a:r>
+            <a:pPr algn="l" indent="0" marL="0">
+              <a:lnSpc>
+                <a:spcPts val="1750"/>
+              </a:lnSpc>
+              <a:buNone/>
+            </a:pPr>
+            <a:r>
+              <a:rPr lang="en-US" sz="1250" dirty="0">
+                <a:solidFill>
+                  <a:srgbClr val="2B2A27"/>
+                </a:solidFill>
+                <a:latin typeface="Geist" pitchFamily="34" charset="0"/>
+                <a:ea typeface="Geist" pitchFamily="34" charset="-122"/>
+                <a:cs typeface="Geist" pitchFamily="34" charset="-120"/>
+              </a:rPr>
+              <a:t>.</a:t>
+            </a:r>
+            <a:endParaRPr lang="en-US" sz="1250" dirty="0"/>
+          </a:p>
+        </p:txBody>
+      </p:sp>
+      <p:sp>
+        <p:nvSpPr>
+          <p:cNvPr id="11" name="text-10"/>
+          <p:cNvSpPr txBox="1"/>
+          <p:nvPr/>
+        </p:nvSpPr>
+        <p:spPr>
+          <a:xfrm>
+            <a:off x="457349" y="7175500"/>
+            <a:ext cx="6024245" cy="444500"/>
+          </a:xfrm>
+          <a:prstGeom prst="rect">
+            <a:avLst/>
+          </a:prstGeom>
+          <a:noFill/>
+          <a:ln/>
+        </p:spPr>
+        <p:txBody>
+          <a:bodyPr wrap="square" lIns="0" tIns="0" rIns="0" bIns="0" rtlCol="0" anchor="t"/>
+          <a:lstStyle/>
+          <a:p>
+            <a:pPr algn="l" indent="0" marL="0">
+              <a:lnSpc>
+                <a:spcPts val="1750"/>
+              </a:lnSpc>
+              <a:buNone/>
+            </a:pPr>
+            <a:r>
+              <a:rPr lang="en-US" sz="1250" dirty="0">
+                <a:solidFill>
+                  <a:srgbClr val="2B2A27"/>
+                </a:solidFill>
+                <a:latin typeface="Geist" pitchFamily="34" charset="0"/>
+                <a:ea typeface="Geist" pitchFamily="34" charset="-122"/>
+                <a:cs typeface="Geist" pitchFamily="34" charset="-120"/>
+              </a:rPr>
+              <a:t>Интервью стояло на 28 февраля, в 2 часа дня. Именно тогда всё пошло не по плану.</a:t>
             </a:r>
             <a:endParaRPr lang="en-US" sz="1250" dirty="0"/>
           </a:p>
@@ -3455,8 +3489,8 @@
         </p:nvSpPr>
         <p:spPr>
           <a:xfrm rot="-120000">
-            <a:off x="2286695" y="4381500"/>
-            <a:ext cx="2120900" cy="400050"/>
+            <a:off x="2287191" y="4381500"/>
+            <a:ext cx="2508250" cy="400050"/>
           </a:xfrm>
           <a:prstGeom prst="roundRect">
             <a:avLst>
@@ -3497,7 +3531,7 @@
         </p:blipFill>
         <p:spPr>
           <a:xfrm rot="-120000">
-            <a:off x="2426207" y="4521680"/>
+            <a:off x="2426325" y="4528457"/>
             <a:ext cx="177800" cy="177800"/>
           </a:xfrm>
           <a:prstGeom prst="rect">
@@ -3513,8 +3547,8 @@
         </p:nvSpPr>
         <p:spPr>
           <a:xfrm rot="-120000">
-            <a:off x="2680317" y="4465968"/>
-            <a:ext cx="1682750" cy="222250"/>
+            <a:off x="2680813" y="4465968"/>
+            <a:ext cx="2093341" cy="222250"/>
           </a:xfrm>
           <a:prstGeom prst="rect">
             <a:avLst/>
@@ -3541,7 +3575,7 @@
                 <a:ea typeface="Geist" pitchFamily="34" charset="-122"/>
                 <a:cs typeface="Geist" pitchFamily="34" charset="-120"/>
               </a:rPr>
-              <a:t>интервью · 1 марта</a:t>
+              <a:t>интервью · 28 февраля</a:t>
             </a:r>
             <a:endParaRPr lang="en-US" sz="1350" dirty="0"/>
           </a:p>
@@ -3670,8 +3704,8 @@
         </p:nvSpPr>
         <p:spPr>
           <a:xfrm>
-            <a:off x="457845" y="406400"/>
-            <a:ext cx="1301750" cy="323850"/>
+            <a:off x="455960" y="406400"/>
+            <a:ext cx="1587500" cy="323850"/>
           </a:xfrm>
           <a:prstGeom prst="roundRect">
             <a:avLst>
@@ -3721,8 +3755,8 @@
         </p:nvSpPr>
         <p:spPr>
           <a:xfrm>
-            <a:off x="788045" y="482600"/>
-            <a:ext cx="895223" cy="171450"/>
+            <a:off x="786160" y="482600"/>
+            <a:ext cx="1198118" cy="171450"/>
           </a:xfrm>
           <a:prstGeom prst="rect">
             <a:avLst/>
@@ -3749,7 +3783,7 @@
                 <a:ea typeface="IBM Plex Mono" pitchFamily="34" charset="-122"/>
                 <a:cs typeface="IBM Plex Mono" pitchFamily="34" charset="-120"/>
               </a:rPr>
-              <a:t>1–9 МАРТА</a:t>
+              <a:t>С 28 ФЕВРАЛЯ</a:t>
             </a:r>
             <a:endParaRPr lang="en-US" sz="1000" dirty="0"/>
           </a:p>
@@ -3864,8 +3898,8 @@
         </p:nvSpPr>
         <p:spPr>
           <a:xfrm>
-            <a:off x="457349" y="1664940"/>
-            <a:ext cx="6024245" cy="717550"/>
+            <a:off x="457349" y="1625600"/>
+            <a:ext cx="6024245" cy="647700"/>
           </a:xfrm>
           <a:prstGeom prst="rect">
             <a:avLst/>
@@ -3879,12 +3913,12 @@
           <a:p>
             <a:pPr algn="l" indent="0" marL="0">
               <a:lnSpc>
-                <a:spcPts val="1890"/>
-              </a:lnSpc>
-              <a:buNone/>
-            </a:pPr>
-            <a:r>
-              <a:rPr lang="en-US" sz="1350" dirty="0">
+                <a:spcPts val="1700"/>
+              </a:lnSpc>
+              <a:buNone/>
+            </a:pPr>
+            <a:r>
+              <a:rPr lang="en-US" sz="1250" dirty="0">
                 <a:solidFill>
                   <a:srgbClr val="2B2A27"/>
                 </a:solidFill>
@@ -3892,9 +3926,9 @@
                 <a:ea typeface="Geist" pitchFamily="34" charset="-122"/>
                 <a:cs typeface="Geist" pitchFamily="34" charset="-120"/>
               </a:rPr>
-              <a:t>В ночь на 1 марта завыла сирена, на телефоны пришёл emergency alert. Мы спустились вниз и три часа просто сидели. Потом разбомбили порт, дым было видно по всему городу. Рейсы отменили.</a:t>
-            </a:r>
-            <a:endParaRPr lang="en-US" sz="1350" dirty="0"/>
+              <a:t>Пока я, нервничая, шёл с другом на интервью после пробной лекции, с неба послышались взрывы. Мы подняли головы и увидели ужасное: в голубом небе Абу-Даби тянулся дым от летящих ракет.</a:t>
+            </a:r>
+            <a:endParaRPr lang="en-US" sz="1250" dirty="0"/>
           </a:p>
         </p:txBody>
       </p:sp>
@@ -3906,8 +3940,8 @@
         </p:nvSpPr>
         <p:spPr>
           <a:xfrm>
-            <a:off x="457349" y="2461171"/>
-            <a:ext cx="6024245" cy="717550"/>
+            <a:off x="456059" y="2343150"/>
+            <a:ext cx="5694426" cy="203200"/>
           </a:xfrm>
           <a:prstGeom prst="rect">
             <a:avLst/>
@@ -3921,45 +3955,87 @@
           <a:p>
             <a:pPr algn="l" indent="0" marL="0">
               <a:lnSpc>
-                <a:spcPts val="1890"/>
-              </a:lnSpc>
-              <a:buNone/>
-            </a:pPr>
-            <a:r>
-              <a:rPr lang="en-US" sz="1350" dirty="0">
-                <a:solidFill>
-                  <a:srgbClr val="2B2A27"/>
+                <a:spcPts val="1700"/>
+              </a:lnSpc>
+              <a:buNone/>
+            </a:pPr>
+            <a:r>
+              <a:rPr lang="en-US" sz="1250" b="1" dirty="0">
+                <a:solidFill>
+                  <a:srgbClr val="0A0A0A"/>
                 </a:solidFill>
                 <a:latin typeface="Geist" pitchFamily="34" charset="0"/>
                 <a:ea typeface="Geist" pitchFamily="34" charset="-122"/>
                 <a:cs typeface="Geist" pitchFamily="34" charset="-120"/>
               </a:rPr>
-              <a:t>Домой нас вывезло посольство Казахстана, рейсом Шарджа – Алматы. Через месяц пришёл оффер с полной стипендией. </a:t>
-            </a:r>
-            <a:pPr algn="l" indent="0" marL="0">
-              <a:lnSpc>
-                <a:spcPts val="1890"/>
-              </a:lnSpc>
-              <a:buNone/>
-            </a:pPr>
-            <a:r>
-              <a:rPr lang="en-US" sz="1350" b="1" dirty="0">
-                <a:solidFill>
-                  <a:srgbClr val="D7261E"/>
+              <a:t>Началась война США с Ираном, а в ОАЭ стоят американские базы.</a:t>
+            </a:r>
+            <a:endParaRPr lang="en-US" sz="1250" dirty="0"/>
+          </a:p>
+        </p:txBody>
+      </p:sp>
+      <p:sp>
+        <p:nvSpPr>
+          <p:cNvPr id="10" name="text-9"/>
+          <p:cNvSpPr txBox="1"/>
+          <p:nvPr/>
+        </p:nvSpPr>
+        <p:spPr>
+          <a:xfrm>
+            <a:off x="457349" y="2616200"/>
+            <a:ext cx="6024245" cy="431800"/>
+          </a:xfrm>
+          <a:prstGeom prst="rect">
+            <a:avLst/>
+          </a:prstGeom>
+          <a:noFill/>
+          <a:ln/>
+        </p:spPr>
+        <p:txBody>
+          <a:bodyPr wrap="square" lIns="0" tIns="0" rIns="0" bIns="0" rtlCol="0" anchor="t"/>
+          <a:lstStyle/>
+          <a:p>
+            <a:pPr algn="l" indent="0" marL="0">
+              <a:lnSpc>
+                <a:spcPts val="1700"/>
+              </a:lnSpc>
+              <a:buNone/>
+            </a:pPr>
+            <a:r>
+              <a:rPr lang="en-US" sz="1250" dirty="0">
+                <a:solidFill>
+                  <a:srgbClr val="2B2A27"/>
                 </a:solidFill>
                 <a:latin typeface="Geist" pitchFamily="34" charset="0"/>
                 <a:ea typeface="Geist" pitchFamily="34" charset="-122"/>
                 <a:cs typeface="Geist" pitchFamily="34" charset="-120"/>
               </a:rPr>
+              <a:t>Домой нас вывезло посольство Казахстана рейсом Шарджа – Алматы. Через месяц пришёл оффер с полной стипендией. </a:t>
+            </a:r>
+            <a:pPr algn="l" indent="0" marL="0">
+              <a:lnSpc>
+                <a:spcPts val="1700"/>
+              </a:lnSpc>
+              <a:buNone/>
+            </a:pPr>
+            <a:r>
+              <a:rPr lang="en-US" sz="1250" b="1" dirty="0">
+                <a:solidFill>
+                  <a:srgbClr val="D7261E"/>
+                </a:solidFill>
+                <a:latin typeface="Geist" pitchFamily="34" charset="0"/>
+                <a:ea typeface="Geist" pitchFamily="34" charset="-122"/>
+                <a:cs typeface="Geist" pitchFamily="34" charset="-120"/>
+              </a:rPr>
               <a:t>Я от него отказался.</a:t>
             </a:r>
-            <a:endParaRPr lang="en-US" sz="1350" dirty="0"/>
-          </a:p>
-        </p:txBody>
-      </p:sp>
-      <p:sp>
-        <p:nvSpPr>
-          <p:cNvPr id="10" name="text-9"/>
+            <a:endParaRPr lang="en-US" sz="1250" dirty="0"/>
+          </a:p>
+        </p:txBody>
+      </p:sp>
+      <p:sp>
+        <p:nvSpPr>
+          <p:cNvPr id="11" name="text-10"/>
           <p:cNvSpPr txBox="1"/>
           <p:nvPr/>
         </p:nvSpPr>
@@ -4001,7 +4077,7 @@
       </p:sp>
       <p:sp>
         <p:nvSpPr>
-          <p:cNvPr id="11" name="shape-10"/>
+          <p:cNvPr id="12" name="shape-11"/>
           <p:cNvSpPr/>
           <p:nvPr/>
         </p:nvSpPr>
@@ -4023,7 +4099,7 @@
       </p:sp>
       <p:sp>
         <p:nvSpPr>
-          <p:cNvPr id="12" name="text-11"/>
+          <p:cNvPr id="13" name="text-12"/>
           <p:cNvSpPr txBox="1"/>
           <p:nvPr/>
         </p:nvSpPr>
@@ -4065,7 +4141,7 @@
       </p:sp>
       <p:pic>
         <p:nvPicPr>
-          <p:cNvPr id="13" name="svg-12" descr="preencoded.png">    </p:cNvPr>
+          <p:cNvPr id="14" name="svg-13" descr="preencoded.png">    </p:cNvPr>
           <p:cNvPicPr>
             <a:picLocks noChangeAspect="1"/>
           </p:cNvPicPr>
@@ -4089,14 +4165,14 @@
       </p:pic>
       <p:sp>
         <p:nvSpPr>
-          <p:cNvPr id="14" name="shape-13"/>
+          <p:cNvPr id="15" name="shape-14"/>
           <p:cNvSpPr/>
           <p:nvPr/>
         </p:nvSpPr>
         <p:spPr>
           <a:xfrm rot="-240000">
-            <a:off x="355600" y="3619500"/>
-            <a:ext cx="2413000" cy="3581400"/>
+            <a:off x="355600" y="3651250"/>
+            <a:ext cx="2159000" cy="3162300"/>
           </a:xfrm>
           <a:prstGeom prst="rect">
             <a:avLst/>
@@ -4116,13 +4192,13 @@
       </p:sp>
       <p:sp>
         <p:nvSpPr>
-          <p:cNvPr id="15" name="shape-14"/>
+          <p:cNvPr id="16" name="shape-15"/>
           <p:cNvSpPr/>
           <p:nvPr/>
         </p:nvSpPr>
         <p:spPr>
           <a:xfrm rot="-420000">
-            <a:off x="1026209" y="3522200"/>
+            <a:off x="913826" y="3553440"/>
             <a:ext cx="825500" cy="254000"/>
           </a:xfrm>
           <a:prstGeom prst="rect">
@@ -4138,7 +4214,7 @@
       </p:sp>
       <p:pic>
         <p:nvPicPr>
-          <p:cNvPr id="16" name="img-15" descr="preencoded.png">    </p:cNvPr>
+          <p:cNvPr id="17" name="img-16" descr="preencoded.png">    </p:cNvPr>
           <p:cNvPicPr>
             <a:picLocks noChangeAspect="1"/>
           </p:cNvPicPr>
@@ -4152,8 +4228,8 @@
         </p:blipFill>
         <p:spPr>
           <a:xfrm rot="-240000">
-            <a:off x="422941" y="3696009"/>
-            <a:ext cx="2260600" cy="3175000"/>
+            <a:off x="410684" y="3715044"/>
+            <a:ext cx="2032000" cy="2794000"/>
           </a:xfrm>
           <a:prstGeom prst="rect">
             <a:avLst/>
@@ -4162,14 +4238,14 @@
       </p:pic>
       <p:sp>
         <p:nvSpPr>
-          <p:cNvPr id="17" name="text-16"/>
+          <p:cNvPr id="18" name="text-17"/>
           <p:cNvSpPr txBox="1"/>
           <p:nvPr/>
         </p:nvSpPr>
         <p:spPr>
           <a:xfrm rot="-240000">
-            <a:off x="417857" y="6860491"/>
-            <a:ext cx="2509520" cy="260350"/>
+            <a:off x="408319" y="6473651"/>
+            <a:ext cx="2245360" cy="260350"/>
           </a:xfrm>
           <a:prstGeom prst="rect">
             <a:avLst/>
@@ -4196,7 +4272,7 @@
                 <a:ea typeface="Noto Serif Display Light" pitchFamily="34" charset="-122"/>
                 <a:cs typeface="Noto Serif Display Light" pitchFamily="34" charset="-120"/>
               </a:rPr>
-              <a:t>мой канал, 1 марта</a:t>
+              <a:t>мой ТГ-канал, 1 марта</a:t>
             </a:r>
             <a:endParaRPr lang="en-US" sz="1500" dirty="0"/>
           </a:p>
@@ -4204,14 +4280,14 @@
       </p:sp>
       <p:sp>
         <p:nvSpPr>
-          <p:cNvPr id="18" name="shape-17"/>
+          <p:cNvPr id="19" name="shape-18"/>
           <p:cNvSpPr/>
           <p:nvPr/>
         </p:nvSpPr>
         <p:spPr>
           <a:xfrm rot="180000">
-            <a:off x="2794000" y="3460750"/>
-            <a:ext cx="3746500" cy="1936750"/>
+            <a:off x="2984500" y="3587750"/>
+            <a:ext cx="3556000" cy="1790700"/>
           </a:xfrm>
           <a:prstGeom prst="rect">
             <a:avLst/>
@@ -4231,13 +4307,13 @@
       </p:sp>
       <p:sp>
         <p:nvSpPr>
-          <p:cNvPr id="19" name="shape-18"/>
+          <p:cNvPr id="20" name="shape-19"/>
           <p:cNvSpPr/>
           <p:nvPr/>
         </p:nvSpPr>
         <p:spPr>
           <a:xfrm>
-            <a:off x="4303852" y="3360442"/>
+            <a:off x="4395280" y="3487342"/>
             <a:ext cx="825500" cy="254000"/>
           </a:xfrm>
           <a:prstGeom prst="rect">
@@ -4253,7 +4329,7 @@
       </p:sp>
       <p:pic>
         <p:nvPicPr>
-          <p:cNvPr id="20" name="img-19" descr="preencoded.png">    </p:cNvPr>
+          <p:cNvPr id="21" name="img-20" descr="preencoded.png">    </p:cNvPr>
           <p:cNvPicPr>
             <a:picLocks noChangeAspect="1"/>
           </p:cNvPicPr>
@@ -4267,8 +4343,8 @@
         </p:blipFill>
         <p:spPr>
           <a:xfrm rot="180000">
-            <a:off x="2870200" y="3536950"/>
-            <a:ext cx="3594100" cy="1784350"/>
+            <a:off x="3048000" y="3651250"/>
+            <a:ext cx="3429000" cy="1663700"/>
           </a:xfrm>
           <a:prstGeom prst="rect">
             <a:avLst/>
@@ -4277,14 +4353,14 @@
       </p:pic>
       <p:sp>
         <p:nvSpPr>
-          <p:cNvPr id="21" name="shape-20"/>
+          <p:cNvPr id="22" name="shape-21"/>
           <p:cNvSpPr/>
           <p:nvPr/>
         </p:nvSpPr>
         <p:spPr>
           <a:xfrm rot="-120000">
-            <a:off x="3683000" y="5524500"/>
-            <a:ext cx="2667000" cy="2311400"/>
+            <a:off x="4064000" y="5429250"/>
+            <a:ext cx="2349500" cy="2247900"/>
           </a:xfrm>
           <a:prstGeom prst="rect">
             <a:avLst/>
@@ -4304,13 +4380,13 @@
       </p:sp>
       <p:sp>
         <p:nvSpPr>
-          <p:cNvPr id="22" name="shape-21"/>
+          <p:cNvPr id="23" name="shape-22"/>
           <p:cNvSpPr/>
           <p:nvPr/>
         </p:nvSpPr>
         <p:spPr>
           <a:xfrm rot="-300000">
-            <a:off x="4564303" y="5423589"/>
+            <a:off x="4787661" y="5328319"/>
             <a:ext cx="825500" cy="254000"/>
           </a:xfrm>
           <a:prstGeom prst="rect">
@@ -4326,7 +4402,7 @@
       </p:sp>
       <p:pic>
         <p:nvPicPr>
-          <p:cNvPr id="23" name="img-22" descr="preencoded.png">    </p:cNvPr>
+          <p:cNvPr id="24" name="img-23" descr="preencoded.png">    </p:cNvPr>
           <p:cNvPicPr>
             <a:picLocks noChangeAspect="1"/>
           </p:cNvPicPr>
@@ -4340,8 +4416,8 @@
         </p:blipFill>
         <p:spPr>
           <a:xfrm rot="-120000">
-            <a:off x="3754768" y="5600778"/>
-            <a:ext cx="2514600" cy="1905000"/>
+            <a:off x="4123289" y="5492823"/>
+            <a:ext cx="2222500" cy="1879600"/>
           </a:xfrm>
           <a:prstGeom prst="rect">
             <a:avLst/>
@@ -4350,14 +4426,14 @@
       </p:pic>
       <p:sp>
         <p:nvSpPr>
-          <p:cNvPr id="24" name="text-23"/>
+          <p:cNvPr id="25" name="text-24"/>
           <p:cNvSpPr txBox="1"/>
           <p:nvPr/>
         </p:nvSpPr>
         <p:spPr>
           <a:xfrm rot="-120000">
-            <a:off x="3662791" y="7498772"/>
-            <a:ext cx="2773680" cy="260350"/>
+            <a:off x="4049033" y="7340041"/>
+            <a:ext cx="2443480" cy="260350"/>
           </a:xfrm>
           <a:prstGeom prst="rect">
             <a:avLst/>
@@ -4392,7 +4468,7 @@
       </p:sp>
       <p:sp>
         <p:nvSpPr>
-          <p:cNvPr id="25" name="shape-24"/>
+          <p:cNvPr id="26" name="shape-25"/>
           <p:cNvSpPr/>
           <p:nvPr/>
         </p:nvSpPr>
@@ -4421,7 +4497,7 @@
       </p:sp>
       <p:pic>
         <p:nvPicPr>
-          <p:cNvPr id="26" name="svg-25" descr="preencoded.png">    </p:cNvPr>
+          <p:cNvPr id="27" name="svg-26" descr="preencoded.png">    </p:cNvPr>
           <p:cNvPicPr>
             <a:picLocks noChangeAspect="1"/>
           </p:cNvPicPr>
@@ -4445,7 +4521,7 @@
       </p:pic>
       <p:sp>
         <p:nvSpPr>
-          <p:cNvPr id="27" name="text-26"/>
+          <p:cNvPr id="28" name="text-27"/>
           <p:cNvSpPr txBox="1"/>
           <p:nvPr/>
         </p:nvSpPr>
@@ -4487,13 +4563,13 @@
       </p:sp>
       <p:sp>
         <p:nvSpPr>
-          <p:cNvPr id="28" name="shape-27"/>
+          <p:cNvPr id="29" name="shape-28"/>
           <p:cNvSpPr/>
           <p:nvPr/>
         </p:nvSpPr>
         <p:spPr>
-          <a:xfrm rot="-360000">
-            <a:off x="2538512" y="5461000"/>
+          <a:xfrm rot="-300000">
+            <a:off x="2094012" y="6826250"/>
             <a:ext cx="2190750" cy="400050"/>
           </a:xfrm>
           <a:prstGeom prst="roundRect">
@@ -4521,7 +4597,7 @@
       </p:sp>
       <p:pic>
         <p:nvPicPr>
-          <p:cNvPr id="29" name="svg-28" descr="preencoded.png">    </p:cNvPr>
+          <p:cNvPr id="30" name="svg-29" descr="preencoded.png">    </p:cNvPr>
           <p:cNvPicPr>
             <a:picLocks noChangeAspect="1"/>
           </p:cNvPicPr>
@@ -4534,8 +4610,8 @@
           </a:stretch>
         </p:blipFill>
         <p:spPr>
-          <a:xfrm rot="-360000">
-            <a:off x="2684440" y="5662572"/>
+          <a:xfrm rot="-300000">
+            <a:off x="2238493" y="7012790"/>
             <a:ext cx="177800" cy="177800"/>
           </a:xfrm>
           <a:prstGeom prst="rect">
@@ -4545,13 +4621,13 @@
       </p:pic>
       <p:sp>
         <p:nvSpPr>
-          <p:cNvPr id="30" name="text-29"/>
+          <p:cNvPr id="31" name="text-30"/>
           <p:cNvSpPr txBox="1"/>
           <p:nvPr/>
         </p:nvSpPr>
         <p:spPr>
-          <a:xfrm rot="-360000">
-            <a:off x="2931516" y="5536625"/>
+          <a:xfrm rot="-300000">
+            <a:off x="2487229" y="6904081"/>
             <a:ext cx="1756791" cy="222250"/>
           </a:xfrm>
           <a:prstGeom prst="rect">
@@ -4835,7 +4911,7 @@
         </p:nvSpPr>
         <p:spPr>
           <a:xfrm>
-            <a:off x="457200" y="5164137"/>
+            <a:off x="457200" y="4666456"/>
             <a:ext cx="6300216" cy="1257300"/>
           </a:xfrm>
           <a:prstGeom prst="rect">
@@ -4894,8 +4970,8 @@
         </p:nvSpPr>
         <p:spPr>
           <a:xfrm>
-            <a:off x="457845" y="6536928"/>
-            <a:ext cx="6246368" cy="495300"/>
+            <a:off x="457845" y="6036667"/>
+            <a:ext cx="6246368" cy="749300"/>
           </a:xfrm>
           <a:prstGeom prst="rect">
             <a:avLst/>
@@ -4922,7 +4998,7 @@
                 <a:ea typeface="Geist" pitchFamily="34" charset="-122"/>
                 <a:cs typeface="Geist" pitchFamily="34" charset="-120"/>
               </a:rPr>
-              <a:t>Война началась прямо в день моего интервью. Жить четыре года рядом с этим я не захотел.</a:t>
+              <a:t>Война началась буквально над моей головой. Жить четыре года рядом с этим я не захотел, несмотря на исключительные гарантии безопасности.</a:t>
             </a:r>
             <a:endParaRPr lang="en-US" sz="1400" dirty="0"/>
           </a:p>
@@ -4936,8 +5012,8 @@
         </p:nvSpPr>
         <p:spPr>
           <a:xfrm>
-            <a:off x="457845" y="7123509"/>
-            <a:ext cx="6246368" cy="495300"/>
+            <a:off x="457845" y="6872089"/>
+            <a:ext cx="6246368" cy="749300"/>
           </a:xfrm>
           <a:prstGeom prst="rect">
             <a:avLst/>
@@ -4964,7 +5040,7 @@
                 <a:ea typeface="Geist" pitchFamily="34" charset="-122"/>
                 <a:cs typeface="Geist" pitchFamily="34" charset="-120"/>
               </a:rPr>
-              <a:t>Трое друзей из той же поездки всё равно поехали учиться, и у них всё хорошо. Каждый решает за себя.</a:t>
+              <a:t>Мои знакомые, которые туда поступили, всё равно поехали учиться. У них всё отлично, они проживают лучшую студенческую жизнь. Всё-таки каждый решает за себя.</a:t>
             </a:r>
             <a:endParaRPr lang="en-US" sz="1400" dirty="0"/>
           </a:p>
@@ -5294,8 +5370,8 @@
         </p:nvSpPr>
         <p:spPr>
           <a:xfrm rot="180000">
-            <a:off x="634901" y="2540000"/>
-            <a:ext cx="2800350" cy="400050"/>
+            <a:off x="635149" y="2540000"/>
+            <a:ext cx="3028950" cy="400050"/>
           </a:xfrm>
           <a:prstGeom prst="roundRect">
             <a:avLst>
@@ -5336,7 +5412,7 @@
         </p:blipFill>
         <p:spPr>
           <a:xfrm rot="180000">
-            <a:off x="776305" y="2589815"/>
+            <a:off x="776462" y="2583820"/>
             <a:ext cx="177800" cy="177800"/>
           </a:xfrm>
           <a:prstGeom prst="rect">
@@ -5352,8 +5428,8 @@
         </p:nvSpPr>
         <p:spPr>
           <a:xfrm rot="180000">
-            <a:off x="1028427" y="2635547"/>
-            <a:ext cx="2402967" cy="222250"/>
+            <a:off x="1028675" y="2635547"/>
+            <a:ext cx="2645283" cy="222250"/>
           </a:xfrm>
           <a:prstGeom prst="rect">
             <a:avLst/>
@@ -5380,7 +5456,7 @@
                 <a:ea typeface="Geist" pitchFamily="34" charset="-122"/>
                 <a:cs typeface="Geist" pitchFamily="34" charset="-120"/>
               </a:rPr>
-              <a:t>3 друга всё равно поехали</a:t>
+              <a:t>знакомые всё равно поехали</a:t>
             </a:r>
             <a:endParaRPr lang="en-US" sz="1350" dirty="0"/>
           </a:p>
@@ -5394,8 +5470,8 @@
         </p:nvSpPr>
         <p:spPr>
           <a:xfrm rot="-240000">
-            <a:off x="506710" y="3554809"/>
-            <a:ext cx="1891411" cy="514350"/>
+            <a:off x="508843" y="3554809"/>
+            <a:ext cx="1278890" cy="514350"/>
           </a:xfrm>
           <a:prstGeom prst="rect">
             <a:avLst/>
@@ -5422,7 +5498,7 @@
                 <a:ea typeface="Noto Serif Display Light" pitchFamily="34" charset="-122"/>
                 <a:cs typeface="Noto Serif Display Light" pitchFamily="34" charset="-120"/>
               </a:rPr>
-              <a:t>каждый решает</a:t>
+              <a:t>и это</a:t>
             </a:r>
             <a:endParaRPr lang="en-US" sz="1800" dirty="0"/>
           </a:p>
@@ -5442,7 +5518,7 @@
                 <a:ea typeface="Noto Serif Display Light" pitchFamily="34" charset="-122"/>
                 <a:cs typeface="Noto Serif Display Light" pitchFamily="34" charset="-120"/>
               </a:rPr>
-              <a:t>сам за себя</a:t>
+              <a:t>нормально</a:t>
             </a:r>
             <a:endParaRPr lang="en-US" sz="1800" dirty="0"/>
           </a:p>
@@ -5808,8 +5884,8 @@
         </p:nvSpPr>
         <p:spPr>
           <a:xfrm>
-            <a:off x="457845" y="2261791"/>
-            <a:ext cx="6246368" cy="495300"/>
+            <a:off x="457845" y="2259211"/>
+            <a:ext cx="6246368" cy="749300"/>
           </a:xfrm>
           <a:prstGeom prst="rect">
             <a:avLst/>
@@ -5836,7 +5912,7 @@
                 <a:ea typeface="Geist" pitchFamily="34" charset="-122"/>
                 <a:cs typeface="Geist" pitchFamily="34" charset="-120"/>
               </a:rPr>
-              <a:t>Мама и папа боялись за меня. Я мог настоять на своём, но не стал: их спокойствие оказалось для меня важнее.</a:t>
+              <a:t>Мама и папа, братья и женгешки, все родственники и друзья очень боялись за меня. Я мог настоять на своём и полететь, но не стал: их спокойствие оказалось для меня важнее.</a:t>
             </a:r>
             <a:endParaRPr lang="en-US" sz="1400" dirty="0"/>
           </a:p>
@@ -5850,8 +5926,8 @@
         </p:nvSpPr>
         <p:spPr>
           <a:xfrm>
-            <a:off x="457845" y="2848372"/>
-            <a:ext cx="6246368" cy="495300"/>
+            <a:off x="457845" y="3094633"/>
+            <a:ext cx="6246368" cy="749300"/>
           </a:xfrm>
           <a:prstGeom prst="rect">
             <a:avLst/>
@@ -5878,7 +5954,7 @@
                 <a:ea typeface="Geist" pitchFamily="34" charset="-122"/>
                 <a:cs typeface="Geist" pitchFamily="34" charset="-120"/>
               </a:rPr>
-              <a:t>Со стороны похоже, будто я просто послушался родителей. Дочитай до четвёртой причины.</a:t>
+              <a:t>Со стороны это выглядит так, будто я просто послушался родителей и отказался от гранта всей своей жизни. Но дочитай до четвёртой причины.</a:t>
             </a:r>
             <a:endParaRPr lang="en-US" sz="1400" dirty="0"/>
           </a:p>
@@ -6663,7 +6739,7 @@
         </p:nvSpPr>
         <p:spPr>
           <a:xfrm>
-            <a:off x="457200" y="5748338"/>
+            <a:off x="457200" y="5499497"/>
             <a:ext cx="6300216" cy="673100"/>
           </a:xfrm>
           <a:prstGeom prst="rect">
@@ -6722,7 +6798,7 @@
         </p:nvSpPr>
         <p:spPr>
           <a:xfrm>
-            <a:off x="457845" y="6536928"/>
+            <a:off x="457845" y="6288088"/>
             <a:ext cx="6246368" cy="495300"/>
           </a:xfrm>
           <a:prstGeom prst="rect">
@@ -6750,33 +6826,8 @@
                 <a:ea typeface="Geist" pitchFamily="34" charset="-122"/>
                 <a:cs typeface="Geist" pitchFamily="34" charset="-120"/>
               </a:rPr>
-              <a:t>Когда подавался, я смотрел на две вещи: престиж и стипендию. В Абу-Даби понял, что этого мало.</a:t>
-            </a:r>
-            <a:endParaRPr lang="en-US" sz="1400" dirty="0"/>
-          </a:p>
-        </p:txBody>
-      </p:sp>
-      <p:sp>
-        <p:nvSpPr>
-          <p:cNvPr id="11" name="text-10"/>
-          <p:cNvSpPr txBox="1"/>
-          <p:nvPr/>
-        </p:nvSpPr>
-        <p:spPr>
-          <a:xfrm>
-            <a:off x="457845" y="7123509"/>
-            <a:ext cx="6246368" cy="495300"/>
-          </a:xfrm>
-          <a:prstGeom prst="rect">
-            <a:avLst/>
-          </a:prstGeom>
-          <a:noFill/>
-          <a:ln/>
-        </p:spPr>
-        <p:txBody>
-          <a:bodyPr wrap="square" lIns="0" tIns="0" rIns="0" bIns="0" rtlCol="0" anchor="t"/>
-          <a:lstStyle/>
-          <a:p>
+              <a:t>Когда подавался, я, как и многие, смотрел на две вещи: престиж и стипендию. В Абу-Даби понял, что этого </a:t>
+            </a:r>
             <a:pPr algn="l" indent="0" marL="0">
               <a:lnSpc>
                 <a:spcPts val="1960"/>
@@ -6784,15 +6835,74 @@
               <a:buNone/>
             </a:pPr>
             <a:r>
-              <a:rPr lang="en-US" sz="1400" dirty="0">
-                <a:solidFill>
-                  <a:srgbClr val="2B2A27"/>
+              <a:rPr lang="en-US" sz="1400" b="1" dirty="0">
+                <a:solidFill>
+                  <a:srgbClr val="0A0A0A"/>
                 </a:solidFill>
                 <a:latin typeface="Geist" pitchFamily="34" charset="0"/>
                 <a:ea typeface="Geist" pitchFamily="34" charset="-122"/>
                 <a:cs typeface="Geist" pitchFamily="34" charset="-120"/>
               </a:rPr>
-              <a:t>Мне понравились люди и культура. Но представить себя там через четыре года я так и не смог. И жару я тоже не полюбил.</a:t>
+              <a:t>мало</a:t>
+            </a:r>
+            <a:pPr algn="l" indent="0" marL="0">
+              <a:lnSpc>
+                <a:spcPts val="1960"/>
+              </a:lnSpc>
+              <a:buNone/>
+            </a:pPr>
+            <a:r>
+              <a:rPr lang="en-US" sz="1400" dirty="0">
+                <a:solidFill>
+                  <a:srgbClr val="2B2A27"/>
+                </a:solidFill>
+                <a:latin typeface="Geist" pitchFamily="34" charset="0"/>
+                <a:ea typeface="Geist" pitchFamily="34" charset="-122"/>
+                <a:cs typeface="Geist" pitchFamily="34" charset="-120"/>
+              </a:rPr>
+              <a:t>.</a:t>
+            </a:r>
+            <a:endParaRPr lang="en-US" sz="1400" dirty="0"/>
+          </a:p>
+        </p:txBody>
+      </p:sp>
+      <p:sp>
+        <p:nvSpPr>
+          <p:cNvPr id="11" name="text-10"/>
+          <p:cNvSpPr txBox="1"/>
+          <p:nvPr/>
+        </p:nvSpPr>
+        <p:spPr>
+          <a:xfrm>
+            <a:off x="457845" y="6872089"/>
+            <a:ext cx="6246368" cy="749300"/>
+          </a:xfrm>
+          <a:prstGeom prst="rect">
+            <a:avLst/>
+          </a:prstGeom>
+          <a:noFill/>
+          <a:ln/>
+        </p:spPr>
+        <p:txBody>
+          <a:bodyPr wrap="square" lIns="0" tIns="0" rIns="0" bIns="0" rtlCol="0" anchor="t"/>
+          <a:lstStyle/>
+          <a:p>
+            <a:pPr algn="l" indent="0" marL="0">
+              <a:lnSpc>
+                <a:spcPts val="1960"/>
+              </a:lnSpc>
+              <a:buNone/>
+            </a:pPr>
+            <a:r>
+              <a:rPr lang="en-US" sz="1400" dirty="0">
+                <a:solidFill>
+                  <a:srgbClr val="2B2A27"/>
+                </a:solidFill>
+                <a:latin typeface="Geist" pitchFamily="34" charset="0"/>
+                <a:ea typeface="Geist" pitchFamily="34" charset="-122"/>
+                <a:cs typeface="Geist" pitchFamily="34" charset="-120"/>
+              </a:rPr>
+              <a:t>Мне понравились люди и культура. Ребята там классные, живые, необычные. Но представить себя там через четыре года я так и не смог. И жару после карагандинских снегопадов я тоже не полюбил.</a:t>
             </a:r>
             <a:endParaRPr lang="en-US" sz="1400" dirty="0"/>
           </a:p>
@@ -7122,7 +7232,7 @@
         </p:nvSpPr>
         <p:spPr>
           <a:xfrm rot="180000">
-            <a:off x="636389" y="2540000"/>
+            <a:off x="634851" y="2540000"/>
             <a:ext cx="1530350" cy="400050"/>
           </a:xfrm>
           <a:prstGeom prst="roundRect">
@@ -7164,7 +7274,7 @@
         </p:blipFill>
         <p:spPr>
           <a:xfrm rot="180000">
-            <a:off x="775437" y="2622970"/>
+            <a:off x="775435" y="2623051"/>
             <a:ext cx="177800" cy="177800"/>
           </a:xfrm>
           <a:prstGeom prst="rect">
@@ -7180,7 +7290,7 @@
         </p:nvSpPr>
         <p:spPr>
           <a:xfrm rot="180000">
-            <a:off x="1029915" y="2635547"/>
+            <a:off x="1028377" y="2635547"/>
             <a:ext cx="1056767" cy="222250"/>
           </a:xfrm>
           <a:prstGeom prst="rect">
@@ -7208,7 +7318,7 @@
                 <a:ea typeface="Geist" pitchFamily="34" charset="-122"/>
                 <a:cs typeface="Geist" pitchFamily="34" charset="-120"/>
               </a:rPr>
-              <a:t>+40° не моё</a:t>
+              <a:t>+35° не моё</a:t>
             </a:r>
             <a:endParaRPr lang="en-US" sz="1350" dirty="0"/>
           </a:p>
@@ -7222,8 +7332,8 @@
         </p:nvSpPr>
         <p:spPr>
           <a:xfrm rot="-240000">
-            <a:off x="506859" y="3554809"/>
-            <a:ext cx="1326007" cy="514350"/>
+            <a:off x="508198" y="3554809"/>
+            <a:ext cx="1554861" cy="514350"/>
           </a:xfrm>
           <a:prstGeom prst="rect">
             <a:avLst/>
@@ -7250,7 +7360,7 @@
                 <a:ea typeface="Noto Serif Display Light" pitchFamily="34" charset="-122"/>
                 <a:cs typeface="Noto Serif Display Light" pitchFamily="34" charset="-120"/>
               </a:rPr>
-              <a:t>люди там</a:t>
+              <a:t>но люди там</a:t>
             </a:r>
             <a:endParaRPr lang="en-US" sz="1800" dirty="0"/>
           </a:p>
@@ -7636,8 +7746,8 @@
         </p:nvSpPr>
         <p:spPr>
           <a:xfrm>
-            <a:off x="457845" y="1677591"/>
-            <a:ext cx="6246368" cy="495300"/>
+            <a:off x="457845" y="1675606"/>
+            <a:ext cx="6246368" cy="996950"/>
           </a:xfrm>
           <a:prstGeom prst="rect">
             <a:avLst/>
@@ -7664,7 +7774,7 @@
                 <a:ea typeface="Geist" pitchFamily="34" charset="-122"/>
                 <a:cs typeface="Geist" pitchFamily="34" charset="-120"/>
               </a:rPr>
-              <a:t>В конце 12 класса я заметил простую вещь. Всё, чего я добился, я выучил сам: химию, историю, SAT, IELTS, даже бодибилдинг.</a:t>
+              <a:t>В конце 12 класса я заметил простую вещь. Всё, чего я добился, я выучил сам: химию, математику, историю, SAT, IELTS, даже бодибилдинг. Я уверен, что могу научиться чему угодно. Поэтому для меня название университета было не главным.</a:t>
             </a:r>
             <a:endParaRPr lang="en-US" sz="1400" dirty="0"/>
           </a:p>
@@ -7678,8 +7788,8 @@
         </p:nvSpPr>
         <p:spPr>
           <a:xfrm>
-            <a:off x="457845" y="2264172"/>
-            <a:ext cx="6246368" cy="495300"/>
+            <a:off x="457845" y="2759869"/>
+            <a:ext cx="6246368" cy="996950"/>
           </a:xfrm>
           <a:prstGeom prst="rect">
             <a:avLst/>
@@ -7706,7 +7816,41 @@
                 <a:ea typeface="Geist" pitchFamily="34" charset="-122"/>
                 <a:cs typeface="Geist" pitchFamily="34" charset="-120"/>
               </a:rPr>
-              <a:t>Хороший университет помогает. Но если место не твоё, семья переживает, а цена слишком высокая, ехать нет смысла.</a:t>
+              <a:t>Конечно, хороший университет помогает: NYUAD дал бы много знакомств, возможностей и знаний. Но если место не твоё, семья переживает, а риск снова оказаться в такой ситуации реален, </a:t>
+            </a:r>
+            <a:pPr algn="l" indent="0" marL="0">
+              <a:lnSpc>
+                <a:spcPts val="1960"/>
+              </a:lnSpc>
+              <a:buNone/>
+            </a:pPr>
+            <a:r>
+              <a:rPr lang="en-US" sz="1400" b="1" dirty="0">
+                <a:solidFill>
+                  <a:srgbClr val="0A0A0A"/>
+                </a:solidFill>
+                <a:latin typeface="Geist" pitchFamily="34" charset="0"/>
+                <a:ea typeface="Geist" pitchFamily="34" charset="-122"/>
+                <a:cs typeface="Geist" pitchFamily="34" charset="-120"/>
+              </a:rPr>
+              <a:t>ехать не было смысла</a:t>
+            </a:r>
+            <a:pPr algn="l" indent="0" marL="0">
+              <a:lnSpc>
+                <a:spcPts val="1960"/>
+              </a:lnSpc>
+              <a:buNone/>
+            </a:pPr>
+            <a:r>
+              <a:rPr lang="en-US" sz="1400" dirty="0">
+                <a:solidFill>
+                  <a:srgbClr val="2B2A27"/>
+                </a:solidFill>
+                <a:latin typeface="Geist" pitchFamily="34" charset="0"/>
+                <a:ea typeface="Geist" pitchFamily="34" charset="-122"/>
+                <a:cs typeface="Geist" pitchFamily="34" charset="-120"/>
+              </a:rPr>
+              <a:t>.</a:t>
             </a:r>
             <a:endParaRPr lang="en-US" sz="1400" dirty="0"/>
           </a:p>
@@ -8036,8 +8180,8 @@
         </p:nvSpPr>
         <p:spPr>
           <a:xfrm rot="-180000">
-            <a:off x="4236889" y="6076950"/>
-            <a:ext cx="2051050" cy="400050"/>
+            <a:off x="4916388" y="6076950"/>
+            <a:ext cx="1371600" cy="400050"/>
           </a:xfrm>
           <a:prstGeom prst="roundRect">
             <a:avLst>
@@ -8078,7 +8222,7 @@
         </p:blipFill>
         <p:spPr>
           <a:xfrm rot="-180000">
-            <a:off x="4379118" y="6229708"/>
+            <a:off x="5058201" y="6211925"/>
             <a:ext cx="177800" cy="177800"/>
           </a:xfrm>
           <a:prstGeom prst="rect">
@@ -8094,8 +8238,8 @@
         </p:nvSpPr>
         <p:spPr>
           <a:xfrm rot="-180000">
-            <a:off x="4630415" y="6159203"/>
-            <a:ext cx="1608709" cy="222250"/>
+            <a:off x="5309914" y="6159203"/>
+            <a:ext cx="888492" cy="222250"/>
           </a:xfrm>
           <a:prstGeom prst="rect">
             <a:avLst/>
@@ -8122,7 +8266,7 @@
                 <a:ea typeface="Geist" pitchFamily="34" charset="-122"/>
                 <a:cs typeface="Geist" pitchFamily="34" charset="-120"/>
               </a:rPr>
-              <a:t>SAT · IELTS · химия</a:t>
+              <a:t>майндсет</a:t>
             </a:r>
             <a:endParaRPr lang="en-US" sz="1350" dirty="0"/>
           </a:p>

</xml_diff>

<commit_message>
Reasons carousel: map on reason 1, chat with mum on reason 2, text-only reason 3, no ad on final slide
Co-Authored-By: Claude Opus 5.5 <noreply@anthropic.com>
Claude-Session: https://claude.ai/code/session_01EUKBNPzc7y2DXSfnei23HU
</commit_message>
<xml_diff>
--- a/social/pptx/reasons-170m.pptx
+++ b/social/pptx/reasons-170m.pptx
@@ -4871,7 +4871,7 @@
         </p:blipFill>
         <p:spPr>
           <a:xfrm>
-            <a:off x="889000" y="1079500"/>
+            <a:off x="5969000" y="2667000"/>
             <a:ext cx="254000" cy="254000"/>
           </a:xfrm>
           <a:prstGeom prst="rect">
@@ -4879,9 +4879,258 @@
           </a:prstGeom>
         </p:spPr>
       </p:pic>
+      <p:sp>
+        <p:nvSpPr>
+          <p:cNvPr id="8" name="text-7"/>
+          <p:cNvSpPr txBox="1"/>
+          <p:nvPr/>
+        </p:nvSpPr>
+        <p:spPr>
+          <a:xfrm>
+            <a:off x="457200" y="4666456"/>
+            <a:ext cx="6300216" cy="1257300"/>
+          </a:xfrm>
+          <a:prstGeom prst="rect">
+            <a:avLst/>
+          </a:prstGeom>
+          <a:noFill/>
+          <a:ln/>
+        </p:spPr>
+        <p:txBody>
+          <a:bodyPr wrap="square" lIns="0" tIns="0" rIns="0" bIns="0" rtlCol="0" anchor="t"/>
+          <a:lstStyle/>
+          <a:p>
+            <a:pPr algn="l" indent="0" marL="0">
+              <a:lnSpc>
+                <a:spcPts val="4600"/>
+              </a:lnSpc>
+              <a:buNone/>
+            </a:pPr>
+            <a:r>
+              <a:rPr lang="en-US" sz="4600" b="1" spc="-160" kern="0" dirty="0">
+                <a:solidFill>
+                  <a:srgbClr val="0A0A0A"/>
+                </a:solidFill>
+                <a:latin typeface="Geist" pitchFamily="34" charset="0"/>
+                <a:ea typeface="Geist" pitchFamily="34" charset="-122"/>
+                <a:cs typeface="Geist" pitchFamily="34" charset="-120"/>
+              </a:rPr>
+              <a:t>Я видел, как всё </a:t>
+            </a:r>
+            <a:pPr algn="l" indent="0" marL="0">
+              <a:lnSpc>
+                <a:spcPts val="4600"/>
+              </a:lnSpc>
+              <a:buNone/>
+            </a:pPr>
+            <a:r>
+              <a:rPr lang="en-US" sz="5200" i="1" spc="-100" kern="0" dirty="0">
+                <a:solidFill>
+                  <a:srgbClr val="57068C"/>
+                </a:solidFill>
+                <a:latin typeface="Noto Serif Display Light" pitchFamily="34" charset="0"/>
+                <a:ea typeface="Noto Serif Display Light" pitchFamily="34" charset="-122"/>
+                <a:cs typeface="Noto Serif Display Light" pitchFamily="34" charset="-120"/>
+              </a:rPr>
+              <a:t>началось</a:t>
+            </a:r>
+            <a:endParaRPr lang="en-US" sz="4600" dirty="0"/>
+          </a:p>
+        </p:txBody>
+      </p:sp>
+      <p:sp>
+        <p:nvSpPr>
+          <p:cNvPr id="9" name="text-8"/>
+          <p:cNvSpPr txBox="1"/>
+          <p:nvPr/>
+        </p:nvSpPr>
+        <p:spPr>
+          <a:xfrm>
+            <a:off x="457845" y="6036667"/>
+            <a:ext cx="6246368" cy="749300"/>
+          </a:xfrm>
+          <a:prstGeom prst="rect">
+            <a:avLst/>
+          </a:prstGeom>
+          <a:noFill/>
+          <a:ln/>
+        </p:spPr>
+        <p:txBody>
+          <a:bodyPr wrap="square" lIns="0" tIns="0" rIns="0" bIns="0" rtlCol="0" anchor="t"/>
+          <a:lstStyle/>
+          <a:p>
+            <a:pPr algn="l" indent="0" marL="0">
+              <a:lnSpc>
+                <a:spcPts val="1960"/>
+              </a:lnSpc>
+              <a:buNone/>
+            </a:pPr>
+            <a:r>
+              <a:rPr lang="en-US" sz="1400" dirty="0">
+                <a:solidFill>
+                  <a:srgbClr val="2B2A27"/>
+                </a:solidFill>
+                <a:latin typeface="Geist" pitchFamily="34" charset="0"/>
+                <a:ea typeface="Geist" pitchFamily="34" charset="-122"/>
+                <a:cs typeface="Geist" pitchFamily="34" charset="-120"/>
+              </a:rPr>
+              <a:t>Война началась буквально над моей головой. Жить четыре года рядом с этим я не захотел, несмотря на исключительные гарантии безопасности.</a:t>
+            </a:r>
+            <a:endParaRPr lang="en-US" sz="1400" dirty="0"/>
+          </a:p>
+        </p:txBody>
+      </p:sp>
+      <p:sp>
+        <p:nvSpPr>
+          <p:cNvPr id="10" name="text-9"/>
+          <p:cNvSpPr txBox="1"/>
+          <p:nvPr/>
+        </p:nvSpPr>
+        <p:spPr>
+          <a:xfrm>
+            <a:off x="457845" y="6872089"/>
+            <a:ext cx="6246368" cy="749300"/>
+          </a:xfrm>
+          <a:prstGeom prst="rect">
+            <a:avLst/>
+          </a:prstGeom>
+          <a:noFill/>
+          <a:ln/>
+        </p:spPr>
+        <p:txBody>
+          <a:bodyPr wrap="square" lIns="0" tIns="0" rIns="0" bIns="0" rtlCol="0" anchor="t"/>
+          <a:lstStyle/>
+          <a:p>
+            <a:pPr algn="l" indent="0" marL="0">
+              <a:lnSpc>
+                <a:spcPts val="1960"/>
+              </a:lnSpc>
+              <a:buNone/>
+            </a:pPr>
+            <a:r>
+              <a:rPr lang="en-US" sz="1400" dirty="0">
+                <a:solidFill>
+                  <a:srgbClr val="2B2A27"/>
+                </a:solidFill>
+                <a:latin typeface="Geist" pitchFamily="34" charset="0"/>
+                <a:ea typeface="Geist" pitchFamily="34" charset="-122"/>
+                <a:cs typeface="Geist" pitchFamily="34" charset="-120"/>
+              </a:rPr>
+              <a:t>Мои знакомые, которые туда поступили, всё равно поехали учиться. У них всё отлично, они проживают лучшую студенческую жизнь. Всё-таки каждый решает за себя.</a:t>
+            </a:r>
+            <a:endParaRPr lang="en-US" sz="1400" dirty="0"/>
+          </a:p>
+        </p:txBody>
+      </p:sp>
+      <p:sp>
+        <p:nvSpPr>
+          <p:cNvPr id="11" name="text-10"/>
+          <p:cNvSpPr txBox="1"/>
+          <p:nvPr/>
+        </p:nvSpPr>
+        <p:spPr>
+          <a:xfrm>
+            <a:off x="457845" y="7969250"/>
+            <a:ext cx="895223" cy="171450"/>
+          </a:xfrm>
+          <a:prstGeom prst="rect">
+            <a:avLst/>
+          </a:prstGeom>
+          <a:noFill/>
+          <a:ln/>
+        </p:spPr>
+        <p:txBody>
+          <a:bodyPr wrap="square" lIns="0" tIns="0" rIns="0" bIns="0" rtlCol="0" anchor="t"/>
+          <a:lstStyle/>
+          <a:p>
+            <a:pPr algn="l" indent="0" marL="0">
+              <a:lnSpc>
+                <a:spcPts val="1200"/>
+              </a:lnSpc>
+              <a:buNone/>
+            </a:pPr>
+            <a:r>
+              <a:rPr lang="en-US" sz="1000" spc="140" kern="0" dirty="0">
+                <a:solidFill>
+                  <a:srgbClr val="0A0A0A"/>
+                </a:solidFill>
+                <a:latin typeface="IBM Plex Mono" pitchFamily="34" charset="0"/>
+                <a:ea typeface="IBM Plex Mono" pitchFamily="34" charset="-122"/>
+                <a:cs typeface="IBM Plex Mono" pitchFamily="34" charset="-120"/>
+              </a:rPr>
+              <a:t>@NURZYCOM</a:t>
+            </a:r>
+            <a:endParaRPr lang="en-US" sz="1000" dirty="0"/>
+          </a:p>
+        </p:txBody>
+      </p:sp>
+      <p:sp>
+        <p:nvSpPr>
+          <p:cNvPr id="12" name="shape-11"/>
+          <p:cNvSpPr/>
+          <p:nvPr/>
+        </p:nvSpPr>
+        <p:spPr>
+          <a:xfrm>
+            <a:off x="5340945" y="7893050"/>
+            <a:ext cx="1060450" cy="323850"/>
+          </a:xfrm>
+          <a:prstGeom prst="roundRect">
+            <a:avLst>
+              <a:gd name="adj" fmla="val 50000"/>
+            </a:avLst>
+          </a:prstGeom>
+          <a:solidFill>
+            <a:srgbClr val="0A0A0A"/>
+          </a:solidFill>
+          <a:ln/>
+        </p:spPr>
+      </p:sp>
+      <p:sp>
+        <p:nvSpPr>
+          <p:cNvPr id="13" name="text-12"/>
+          <p:cNvSpPr txBox="1"/>
+          <p:nvPr/>
+        </p:nvSpPr>
+        <p:spPr>
+          <a:xfrm>
+            <a:off x="5480645" y="7969250"/>
+            <a:ext cx="599059" cy="171450"/>
+          </a:xfrm>
+          <a:prstGeom prst="rect">
+            <a:avLst/>
+          </a:prstGeom>
+          <a:noFill/>
+          <a:ln/>
+        </p:spPr>
+        <p:txBody>
+          <a:bodyPr wrap="square" lIns="0" tIns="0" rIns="0" bIns="0" rtlCol="0" anchor="t"/>
+          <a:lstStyle/>
+          <a:p>
+            <a:pPr algn="l" indent="0" marL="0">
+              <a:lnSpc>
+                <a:spcPts val="1200"/>
+              </a:lnSpc>
+              <a:buNone/>
+            </a:pPr>
+            <a:r>
+              <a:rPr lang="en-US" sz="1000" spc="140" kern="0" dirty="0">
+                <a:solidFill>
+                  <a:srgbClr val="FAF8F3"/>
+                </a:solidFill>
+                <a:latin typeface="IBM Plex Mono" pitchFamily="34" charset="0"/>
+                <a:ea typeface="IBM Plex Mono" pitchFamily="34" charset="-122"/>
+                <a:cs typeface="IBM Plex Mono" pitchFamily="34" charset="-120"/>
+              </a:rPr>
+              <a:t>ЛИСТАЙ</a:t>
+            </a:r>
+            <a:endParaRPr lang="en-US" sz="1000" dirty="0"/>
+          </a:p>
+        </p:txBody>
+      </p:sp>
       <p:pic>
         <p:nvPicPr>
-          <p:cNvPr id="8" name="svg-7" descr="preencoded.png">    </p:cNvPr>
+          <p:cNvPr id="14" name="svg-13" descr="preencoded.png">    </p:cNvPr>
           <p:cNvPicPr>
             <a:picLocks noChangeAspect="1"/>
           </p:cNvPicPr>
@@ -4895,8 +5144,8 @@
         </p:blipFill>
         <p:spPr>
           <a:xfrm>
-            <a:off x="2984500" y="4381500"/>
-            <a:ext cx="190500" cy="190500"/>
+            <a:off x="6121400" y="7985125"/>
+            <a:ext cx="139700" cy="139700"/>
           </a:xfrm>
           <a:prstGeom prst="rect">
             <a:avLst/>
@@ -4905,256 +5154,56 @@
       </p:pic>
       <p:sp>
         <p:nvSpPr>
-          <p:cNvPr id="9" name="text-8"/>
-          <p:cNvSpPr txBox="1"/>
-          <p:nvPr/>
-        </p:nvSpPr>
-        <p:spPr>
-          <a:xfrm>
-            <a:off x="457200" y="4666456"/>
-            <a:ext cx="6300216" cy="1257300"/>
-          </a:xfrm>
-          <a:prstGeom prst="rect">
-            <a:avLst/>
-          </a:prstGeom>
-          <a:noFill/>
-          <a:ln/>
-        </p:spPr>
-        <p:txBody>
-          <a:bodyPr wrap="square" lIns="0" tIns="0" rIns="0" bIns="0" rtlCol="0" anchor="t"/>
-          <a:lstStyle/>
-          <a:p>
-            <a:pPr algn="l" indent="0" marL="0">
-              <a:lnSpc>
-                <a:spcPts val="4600"/>
-              </a:lnSpc>
-              <a:buNone/>
-            </a:pPr>
-            <a:r>
-              <a:rPr lang="en-US" sz="4600" b="1" spc="-160" kern="0" dirty="0">
-                <a:solidFill>
-                  <a:srgbClr val="0A0A0A"/>
-                </a:solidFill>
-                <a:latin typeface="Geist" pitchFamily="34" charset="0"/>
-                <a:ea typeface="Geist" pitchFamily="34" charset="-122"/>
-                <a:cs typeface="Geist" pitchFamily="34" charset="-120"/>
-              </a:rPr>
-              <a:t>Я видел, как всё </a:t>
-            </a:r>
-            <a:pPr algn="l" indent="0" marL="0">
-              <a:lnSpc>
-                <a:spcPts val="4600"/>
-              </a:lnSpc>
-              <a:buNone/>
-            </a:pPr>
-            <a:r>
-              <a:rPr lang="en-US" sz="5200" i="1" spc="-100" kern="0" dirty="0">
-                <a:solidFill>
-                  <a:srgbClr val="57068C"/>
-                </a:solidFill>
-                <a:latin typeface="Noto Serif Display Light" pitchFamily="34" charset="0"/>
-                <a:ea typeface="Noto Serif Display Light" pitchFamily="34" charset="-122"/>
-                <a:cs typeface="Noto Serif Display Light" pitchFamily="34" charset="-120"/>
-              </a:rPr>
-              <a:t>началось</a:t>
-            </a:r>
-            <a:endParaRPr lang="en-US" sz="4600" dirty="0"/>
-          </a:p>
-        </p:txBody>
-      </p:sp>
-      <p:sp>
-        <p:nvSpPr>
-          <p:cNvPr id="10" name="text-9"/>
-          <p:cNvSpPr txBox="1"/>
-          <p:nvPr/>
-        </p:nvSpPr>
-        <p:spPr>
-          <a:xfrm>
-            <a:off x="457845" y="6036667"/>
-            <a:ext cx="6246368" cy="749300"/>
-          </a:xfrm>
-          <a:prstGeom prst="rect">
-            <a:avLst/>
-          </a:prstGeom>
-          <a:noFill/>
-          <a:ln/>
-        </p:spPr>
-        <p:txBody>
-          <a:bodyPr wrap="square" lIns="0" tIns="0" rIns="0" bIns="0" rtlCol="0" anchor="t"/>
-          <a:lstStyle/>
-          <a:p>
-            <a:pPr algn="l" indent="0" marL="0">
-              <a:lnSpc>
-                <a:spcPts val="1960"/>
-              </a:lnSpc>
-              <a:buNone/>
-            </a:pPr>
-            <a:r>
-              <a:rPr lang="en-US" sz="1400" dirty="0">
-                <a:solidFill>
-                  <a:srgbClr val="2B2A27"/>
-                </a:solidFill>
-                <a:latin typeface="Geist" pitchFamily="34" charset="0"/>
-                <a:ea typeface="Geist" pitchFamily="34" charset="-122"/>
-                <a:cs typeface="Geist" pitchFamily="34" charset="-120"/>
-              </a:rPr>
-              <a:t>Война началась буквально над моей головой. Жить четыре года рядом с этим я не захотел, несмотря на исключительные гарантии безопасности.</a:t>
-            </a:r>
-            <a:endParaRPr lang="en-US" sz="1400" dirty="0"/>
-          </a:p>
-        </p:txBody>
-      </p:sp>
-      <p:sp>
-        <p:nvSpPr>
-          <p:cNvPr id="11" name="text-10"/>
-          <p:cNvSpPr txBox="1"/>
-          <p:nvPr/>
-        </p:nvSpPr>
-        <p:spPr>
-          <a:xfrm>
-            <a:off x="457845" y="6872089"/>
-            <a:ext cx="6246368" cy="749300"/>
-          </a:xfrm>
-          <a:prstGeom prst="rect">
-            <a:avLst/>
-          </a:prstGeom>
-          <a:noFill/>
-          <a:ln/>
-        </p:spPr>
-        <p:txBody>
-          <a:bodyPr wrap="square" lIns="0" tIns="0" rIns="0" bIns="0" rtlCol="0" anchor="t"/>
-          <a:lstStyle/>
-          <a:p>
-            <a:pPr algn="l" indent="0" marL="0">
-              <a:lnSpc>
-                <a:spcPts val="1960"/>
-              </a:lnSpc>
-              <a:buNone/>
-            </a:pPr>
-            <a:r>
-              <a:rPr lang="en-US" sz="1400" dirty="0">
-                <a:solidFill>
-                  <a:srgbClr val="2B2A27"/>
-                </a:solidFill>
-                <a:latin typeface="Geist" pitchFamily="34" charset="0"/>
-                <a:ea typeface="Geist" pitchFamily="34" charset="-122"/>
-                <a:cs typeface="Geist" pitchFamily="34" charset="-120"/>
-              </a:rPr>
-              <a:t>Мои знакомые, которые туда поступили, всё равно поехали учиться. У них всё отлично, они проживают лучшую студенческую жизнь. Всё-таки каждый решает за себя.</a:t>
-            </a:r>
-            <a:endParaRPr lang="en-US" sz="1400" dirty="0"/>
-          </a:p>
-        </p:txBody>
-      </p:sp>
-      <p:sp>
-        <p:nvSpPr>
-          <p:cNvPr id="12" name="text-11"/>
-          <p:cNvSpPr txBox="1"/>
-          <p:nvPr/>
-        </p:nvSpPr>
-        <p:spPr>
-          <a:xfrm>
-            <a:off x="457845" y="7969250"/>
-            <a:ext cx="895223" cy="171450"/>
-          </a:xfrm>
-          <a:prstGeom prst="rect">
-            <a:avLst/>
-          </a:prstGeom>
-          <a:noFill/>
-          <a:ln/>
-        </p:spPr>
-        <p:txBody>
-          <a:bodyPr wrap="square" lIns="0" tIns="0" rIns="0" bIns="0" rtlCol="0" anchor="t"/>
-          <a:lstStyle/>
-          <a:p>
-            <a:pPr algn="l" indent="0" marL="0">
-              <a:lnSpc>
-                <a:spcPts val="1200"/>
-              </a:lnSpc>
-              <a:buNone/>
-            </a:pPr>
-            <a:r>
-              <a:rPr lang="en-US" sz="1000" spc="140" kern="0" dirty="0">
-                <a:solidFill>
-                  <a:srgbClr val="0A0A0A"/>
-                </a:solidFill>
-                <a:latin typeface="IBM Plex Mono" pitchFamily="34" charset="0"/>
-                <a:ea typeface="IBM Plex Mono" pitchFamily="34" charset="-122"/>
-                <a:cs typeface="IBM Plex Mono" pitchFamily="34" charset="-120"/>
-              </a:rPr>
-              <a:t>@NURZYCOM</a:t>
-            </a:r>
-            <a:endParaRPr lang="en-US" sz="1000" dirty="0"/>
-          </a:p>
-        </p:txBody>
-      </p:sp>
-      <p:sp>
-        <p:nvSpPr>
-          <p:cNvPr id="13" name="shape-12"/>
+          <p:cNvPr id="15" name="shape-14"/>
           <p:cNvSpPr/>
           <p:nvPr/>
         </p:nvSpPr>
         <p:spPr>
-          <a:xfrm>
-            <a:off x="5340945" y="7893050"/>
-            <a:ext cx="1060450" cy="323850"/>
-          </a:xfrm>
-          <a:prstGeom prst="roundRect">
-            <a:avLst>
-              <a:gd name="adj" fmla="val 50000"/>
-            </a:avLst>
+          <a:xfrm rot="-180000">
+            <a:off x="381000" y="889000"/>
+            <a:ext cx="3810000" cy="2908300"/>
+          </a:xfrm>
+          <a:prstGeom prst="rect">
+            <a:avLst/>
           </a:prstGeom>
           <a:solidFill>
-            <a:srgbClr val="0A0A0A"/>
+            <a:srgbClr val="FFFFFF"/>
           </a:solidFill>
           <a:ln/>
-        </p:spPr>
-      </p:sp>
-      <p:sp>
-        <p:nvSpPr>
-          <p:cNvPr id="14" name="text-13"/>
-          <p:cNvSpPr txBox="1"/>
-          <p:nvPr/>
-        </p:nvSpPr>
-        <p:spPr>
-          <a:xfrm>
-            <a:off x="5480645" y="7969250"/>
-            <a:ext cx="599059" cy="171450"/>
-          </a:xfrm>
-          <a:prstGeom prst="rect">
-            <a:avLst/>
-          </a:prstGeom>
-          <a:noFill/>
-          <a:ln/>
-        </p:spPr>
-        <p:txBody>
-          <a:bodyPr wrap="square" lIns="0" tIns="0" rIns="0" bIns="0" rtlCol="0" anchor="t"/>
-          <a:lstStyle/>
-          <a:p>
-            <a:pPr algn="l" indent="0" marL="0">
-              <a:lnSpc>
-                <a:spcPts val="1200"/>
-              </a:lnSpc>
-              <a:buNone/>
-            </a:pPr>
-            <a:r>
-              <a:rPr lang="en-US" sz="1000" spc="140" kern="0" dirty="0">
-                <a:solidFill>
-                  <a:srgbClr val="FAF8F3"/>
-                </a:solidFill>
-                <a:latin typeface="IBM Plex Mono" pitchFamily="34" charset="0"/>
-                <a:ea typeface="IBM Plex Mono" pitchFamily="34" charset="-122"/>
-                <a:cs typeface="IBM Plex Mono" pitchFamily="34" charset="-120"/>
-              </a:rPr>
-              <a:t>ЛИСТАЙ</a:t>
-            </a:r>
-            <a:endParaRPr lang="en-US" sz="1000" dirty="0"/>
-          </a:p>
-        </p:txBody>
+          <a:effectLst>
+            <a:outerShdw sx="100000" sy="100000" kx="0" ky="0" algn="bl" rotWithShape="0" blurRad="177800" dist="76200" dir="5400000">
+              <a:srgbClr val="000000">
+                <a:alpha val="22000"/>
+              </a:srgbClr>
+            </a:outerShdw>
+          </a:effectLst>
+        </p:spPr>
+      </p:sp>
+      <p:sp>
+        <p:nvSpPr>
+          <p:cNvPr id="16" name="shape-15"/>
+          <p:cNvSpPr/>
+          <p:nvPr/>
+        </p:nvSpPr>
+        <p:spPr>
+          <a:xfrm rot="-360000">
+            <a:off x="1798475" y="789358"/>
+            <a:ext cx="825500" cy="254000"/>
+          </a:xfrm>
+          <a:prstGeom prst="rect">
+            <a:avLst/>
+          </a:prstGeom>
+          <a:solidFill>
+            <a:srgbClr val="D5D5D4">
+              <a:alpha val="90000"/>
+            </a:srgbClr>
+          </a:solidFill>
+          <a:ln/>
+        </p:spPr>
       </p:sp>
       <p:pic>
         <p:nvPicPr>
-          <p:cNvPr id="15" name="svg-14" descr="preencoded.png">    </p:cNvPr>
+          <p:cNvPr id="17" name="img-16" descr="preencoded.png">    </p:cNvPr>
           <p:cNvPicPr>
             <a:picLocks noChangeAspect="1"/>
           </p:cNvPicPr>
@@ -5167,9 +5216,9 @@
           </a:stretch>
         </p:blipFill>
         <p:spPr>
-          <a:xfrm>
-            <a:off x="6121400" y="7985125"/>
-            <a:ext cx="139700" cy="139700"/>
+          <a:xfrm rot="-180000">
+            <a:off x="462589" y="978091"/>
+            <a:ext cx="3632200" cy="2451100"/>
           </a:xfrm>
           <a:prstGeom prst="rect">
             <a:avLst/>
@@ -5178,20 +5227,64 @@
       </p:pic>
       <p:sp>
         <p:nvSpPr>
-          <p:cNvPr id="16" name="shape-15"/>
+          <p:cNvPr id="18" name="text-17"/>
+          <p:cNvSpPr txBox="1"/>
+          <p:nvPr/>
+        </p:nvSpPr>
+        <p:spPr>
+          <a:xfrm rot="-180000">
+            <a:off x="370103" y="3459040"/>
+            <a:ext cx="3962400" cy="260350"/>
+          </a:xfrm>
+          <a:prstGeom prst="rect">
+            <a:avLst/>
+          </a:prstGeom>
+          <a:noFill/>
+          <a:ln/>
+        </p:spPr>
+        <p:txBody>
+          <a:bodyPr wrap="square" lIns="0" tIns="0" rIns="0" bIns="0" rtlCol="0" anchor="t"/>
+          <a:lstStyle/>
+          <a:p>
+            <a:pPr algn="ctr" indent="0" marL="0">
+              <a:lnSpc>
+                <a:spcPts val="1800"/>
+              </a:lnSpc>
+              <a:buNone/>
+            </a:pPr>
+            <a:r>
+              <a:rPr lang="en-US" sz="1500" i="1" dirty="0">
+                <a:solidFill>
+                  <a:srgbClr val="0A0A0A"/>
+                </a:solidFill>
+                <a:latin typeface="Noto Serif Display Light" pitchFamily="34" charset="0"/>
+                <a:ea typeface="Noto Serif Display Light" pitchFamily="34" charset="-122"/>
+                <a:cs typeface="Noto Serif Display Light" pitchFamily="34" charset="-120"/>
+              </a:rPr>
+              <a:t>Ближний Восток, весна 2026</a:t>
+            </a:r>
+            <a:endParaRPr lang="en-US" sz="1500" dirty="0"/>
+          </a:p>
+        </p:txBody>
+      </p:sp>
+      <p:sp>
+        <p:nvSpPr>
+          <p:cNvPr id="19" name="shape-18"/>
           <p:cNvSpPr/>
           <p:nvPr/>
         </p:nvSpPr>
         <p:spPr>
           <a:xfrm rot="240000">
-            <a:off x="3302000" y="889000"/>
-            <a:ext cx="2984500" cy="3556000"/>
-          </a:xfrm>
-          <a:prstGeom prst="rect">
-            <a:avLst/>
+            <a:off x="4102348" y="3175000"/>
+            <a:ext cx="2374900" cy="374650"/>
+          </a:xfrm>
+          <a:prstGeom prst="roundRect">
+            <a:avLst>
+              <a:gd name="adj" fmla="val 50000"/>
+            </a:avLst>
           </a:prstGeom>
           <a:solidFill>
-            <a:srgbClr val="FFFFFF"/>
+            <a:srgbClr val="57068C"/>
           </a:solidFill>
           <a:ln/>
           <a:effectLst>
@@ -5203,38 +5296,40 @@
           </a:effectLst>
         </p:spPr>
       </p:sp>
-      <p:sp>
-        <p:nvSpPr>
-          <p:cNvPr id="17" name="shape-16"/>
-          <p:cNvSpPr/>
-          <p:nvPr/>
-        </p:nvSpPr>
-        <p:spPr>
-          <a:xfrm rot="60000">
-            <a:off x="4503755" y="791669"/>
-            <a:ext cx="825500" cy="254000"/>
-          </a:xfrm>
-          <a:prstGeom prst="rect">
-            <a:avLst/>
-          </a:prstGeom>
-          <a:solidFill>
-            <a:srgbClr val="D5D5D4">
-              <a:alpha val="90000"/>
-            </a:srgbClr>
-          </a:solidFill>
-          <a:ln/>
-        </p:spPr>
-      </p:sp>
-      <p:sp>
-        <p:nvSpPr>
-          <p:cNvPr id="18" name="text-17"/>
+      <p:pic>
+        <p:nvPicPr>
+          <p:cNvPr id="20" name="svg-19" descr="preencoded.png">    </p:cNvPr>
+          <p:cNvPicPr>
+            <a:picLocks noChangeAspect="1"/>
+          </p:cNvPicPr>
+          <p:nvPr/>
+        </p:nvPicPr>
+        <p:blipFill>
+          <a:blip r:embed="rId6"/>
+          <a:stretch>
+            <a:fillRect/>
+          </a:stretch>
+        </p:blipFill>
+        <p:spPr>
+          <a:xfrm rot="240000">
+            <a:off x="4231962" y="3205670"/>
+            <a:ext cx="177800" cy="177800"/>
+          </a:xfrm>
+          <a:prstGeom prst="rect">
+            <a:avLst/>
+          </a:prstGeom>
+        </p:spPr>
+      </p:pic>
+      <p:sp>
+        <p:nvSpPr>
+          <p:cNvPr id="21" name="text-20"/>
           <p:cNvSpPr txBox="1"/>
           <p:nvPr/>
         </p:nvSpPr>
         <p:spPr>
           <a:xfrm rot="240000">
-            <a:off x="3847385" y="762306"/>
-            <a:ext cx="2026031" cy="3556000"/>
+            <a:off x="4483039" y="3260059"/>
+            <a:ext cx="1978914" cy="222250"/>
           </a:xfrm>
           <a:prstGeom prst="rect">
             <a:avLst/>
@@ -5248,12 +5343,54 @@
           <a:p>
             <a:pPr algn="l" indent="0" marL="0">
               <a:lnSpc>
-                <a:spcPts val="28000"/>
-              </a:lnSpc>
-              <a:buNone/>
-            </a:pPr>
-            <a:r>
-              <a:rPr lang="en-US" sz="28000" i="1" dirty="0">
+                <a:spcPts val="1620"/>
+              </a:lnSpc>
+              <a:buNone/>
+            </a:pPr>
+            <a:r>
+              <a:rPr lang="en-US" sz="1350" b="1" spc="-10" kern="0" dirty="0">
+                <a:solidFill>
+                  <a:srgbClr val="FAF8F3"/>
+                </a:solidFill>
+                <a:latin typeface="Geist" pitchFamily="34" charset="0"/>
+                <a:ea typeface="Geist" pitchFamily="34" charset="-122"/>
+                <a:cs typeface="Geist" pitchFamily="34" charset="-120"/>
+              </a:rPr>
+              <a:t>обстановка в регионе</a:t>
+            </a:r>
+            <a:endParaRPr lang="en-US" sz="1350" dirty="0"/>
+          </a:p>
+        </p:txBody>
+      </p:sp>
+      <p:sp>
+        <p:nvSpPr>
+          <p:cNvPr id="22" name="text-21"/>
+          <p:cNvSpPr txBox="1"/>
+          <p:nvPr/>
+        </p:nvSpPr>
+        <p:spPr>
+          <a:xfrm rot="-240000">
+            <a:off x="5070267" y="3745309"/>
+            <a:ext cx="1278890" cy="514350"/>
+          </a:xfrm>
+          <a:prstGeom prst="rect">
+            <a:avLst/>
+          </a:prstGeom>
+          <a:noFill/>
+          <a:ln/>
+        </p:spPr>
+        <p:txBody>
+          <a:bodyPr wrap="square" lIns="0" tIns="0" rIns="0" bIns="0" rtlCol="0" anchor="t"/>
+          <a:lstStyle/>
+          <a:p>
+            <a:pPr algn="r" indent="0" marL="0">
+              <a:lnSpc>
+                <a:spcPts val="2020"/>
+              </a:lnSpc>
+              <a:buNone/>
+            </a:pPr>
+            <a:r>
+              <a:rPr lang="en-US" sz="1800" i="1" dirty="0">
                 <a:solidFill>
                   <a:srgbClr val="0A0A0A"/>
                 </a:solidFill>
@@ -5261,27 +5398,45 @@
                 <a:ea typeface="Noto Serif Display Light" pitchFamily="34" charset="-122"/>
                 <a:cs typeface="Noto Serif Display Light" pitchFamily="34" charset="-120"/>
               </a:rPr>
-              <a:t>1</a:t>
-            </a:r>
-            <a:endParaRPr lang="en-US" sz="28000" dirty="0"/>
-          </a:p>
-        </p:txBody>
-      </p:sp>
-      <p:sp>
-        <p:nvSpPr>
-          <p:cNvPr id="19" name="shape-18"/>
+              <a:t>и это</a:t>
+            </a:r>
+            <a:endParaRPr lang="en-US" sz="1800" dirty="0"/>
+          </a:p>
+          <a:p>
+            <a:pPr algn="r" indent="0" marL="0">
+              <a:lnSpc>
+                <a:spcPts val="2020"/>
+              </a:lnSpc>
+              <a:buNone/>
+            </a:pPr>
+            <a:r>
+              <a:rPr lang="en-US" sz="1800" i="1" dirty="0">
+                <a:solidFill>
+                  <a:srgbClr val="0A0A0A"/>
+                </a:solidFill>
+                <a:latin typeface="Noto Serif Display Light" pitchFamily="34" charset="0"/>
+                <a:ea typeface="Noto Serif Display Light" pitchFamily="34" charset="-122"/>
+                <a:cs typeface="Noto Serif Display Light" pitchFamily="34" charset="-120"/>
+              </a:rPr>
+              <a:t>нормально</a:t>
+            </a:r>
+            <a:endParaRPr lang="en-US" sz="1800" dirty="0"/>
+          </a:p>
+        </p:txBody>
+      </p:sp>
+      <p:sp>
+        <p:nvSpPr>
+          <p:cNvPr id="23" name="shape-22"/>
           <p:cNvSpPr/>
           <p:nvPr/>
         </p:nvSpPr>
         <p:spPr>
-          <a:xfrm rot="-300000">
-            <a:off x="406152" y="1587500"/>
-            <a:ext cx="2374900" cy="374650"/>
-          </a:xfrm>
-          <a:prstGeom prst="roundRect">
-            <a:avLst>
-              <a:gd name="adj" fmla="val 50000"/>
-            </a:avLst>
+          <a:xfrm rot="-360000">
+            <a:off x="3810000" y="3429000"/>
+            <a:ext cx="584200" cy="584200"/>
+          </a:xfrm>
+          <a:prstGeom prst="ellipse">
+            <a:avLst/>
           </a:prstGeom>
           <a:solidFill>
             <a:srgbClr val="57068C"/>
@@ -5298,22 +5453,22 @@
       </p:sp>
       <p:pic>
         <p:nvPicPr>
-          <p:cNvPr id="20" name="svg-19" descr="preencoded.png">    </p:cNvPr>
+          <p:cNvPr id="24" name="svg-23" descr="preencoded.png">    </p:cNvPr>
           <p:cNvPicPr>
             <a:picLocks noChangeAspect="1"/>
           </p:cNvPicPr>
           <p:nvPr/>
         </p:nvPicPr>
         <p:blipFill>
-          <a:blip r:embed="rId6"/>
+          <a:blip r:embed="rId7"/>
           <a:stretch>
             <a:fillRect/>
           </a:stretch>
         </p:blipFill>
         <p:spPr>
-          <a:xfrm rot="-300000">
-            <a:off x="537096" y="1770580"/>
-            <a:ext cx="177800" cy="177800"/>
+          <a:xfrm rot="-360000">
+            <a:off x="3956050" y="3575050"/>
+            <a:ext cx="292100" cy="292100"/>
           </a:xfrm>
           <a:prstGeom prst="rect">
             <a:avLst/>
@@ -5322,55 +5477,13 @@
       </p:pic>
       <p:sp>
         <p:nvSpPr>
-          <p:cNvPr id="21" name="text-20"/>
-          <p:cNvSpPr txBox="1"/>
-          <p:nvPr/>
-        </p:nvSpPr>
-        <p:spPr>
-          <a:xfrm rot="-300000">
-            <a:off x="786669" y="1652631"/>
-            <a:ext cx="1978914" cy="222250"/>
-          </a:xfrm>
-          <a:prstGeom prst="rect">
-            <a:avLst/>
-          </a:prstGeom>
-          <a:noFill/>
-          <a:ln/>
-        </p:spPr>
-        <p:txBody>
-          <a:bodyPr wrap="square" lIns="0" tIns="0" rIns="0" bIns="0" rtlCol="0" anchor="t"/>
-          <a:lstStyle/>
-          <a:p>
-            <a:pPr algn="l" indent="0" marL="0">
-              <a:lnSpc>
-                <a:spcPts val="1620"/>
-              </a:lnSpc>
-              <a:buNone/>
-            </a:pPr>
-            <a:r>
-              <a:rPr lang="en-US" sz="1350" b="1" spc="-10" kern="0" dirty="0">
-                <a:solidFill>
-                  <a:srgbClr val="FAF8F3"/>
-                </a:solidFill>
-                <a:latin typeface="Geist" pitchFamily="34" charset="0"/>
-                <a:ea typeface="Geist" pitchFamily="34" charset="-122"/>
-                <a:cs typeface="Geist" pitchFamily="34" charset="-120"/>
-              </a:rPr>
-              <a:t>обстановка в регионе</a:t>
-            </a:r>
-            <a:endParaRPr lang="en-US" sz="1350" dirty="0"/>
-          </a:p>
-        </p:txBody>
-      </p:sp>
-      <p:sp>
-        <p:nvSpPr>
-          <p:cNvPr id="22" name="shape-21"/>
+          <p:cNvPr id="25" name="shape-24"/>
           <p:cNvSpPr/>
           <p:nvPr/>
         </p:nvSpPr>
         <p:spPr>
-          <a:xfrm rot="180000">
-            <a:off x="635149" y="2540000"/>
+          <a:xfrm rot="360000">
+            <a:off x="3473301" y="952500"/>
             <a:ext cx="3028950" cy="400050"/>
           </a:xfrm>
           <a:prstGeom prst="roundRect">
@@ -5398,162 +5511,7 @@
       </p:sp>
       <p:pic>
         <p:nvPicPr>
-          <p:cNvPr id="23" name="svg-22" descr="preencoded.png">    </p:cNvPr>
-          <p:cNvPicPr>
-            <a:picLocks noChangeAspect="1"/>
-          </p:cNvPicPr>
-          <p:nvPr/>
-        </p:nvPicPr>
-        <p:blipFill>
-          <a:blip r:embed="rId7"/>
-          <a:stretch>
-            <a:fillRect/>
-          </a:stretch>
-        </p:blipFill>
-        <p:spPr>
-          <a:xfrm rot="180000">
-            <a:off x="776462" y="2583820"/>
-            <a:ext cx="177800" cy="177800"/>
-          </a:xfrm>
-          <a:prstGeom prst="rect">
-            <a:avLst/>
-          </a:prstGeom>
-        </p:spPr>
-      </p:pic>
-      <p:sp>
-        <p:nvSpPr>
-          <p:cNvPr id="24" name="text-23"/>
-          <p:cNvSpPr txBox="1"/>
-          <p:nvPr/>
-        </p:nvSpPr>
-        <p:spPr>
-          <a:xfrm rot="180000">
-            <a:off x="1028675" y="2635547"/>
-            <a:ext cx="2645283" cy="222250"/>
-          </a:xfrm>
-          <a:prstGeom prst="rect">
-            <a:avLst/>
-          </a:prstGeom>
-          <a:noFill/>
-          <a:ln/>
-        </p:spPr>
-        <p:txBody>
-          <a:bodyPr wrap="square" lIns="0" tIns="0" rIns="0" bIns="0" rtlCol="0" anchor="t"/>
-          <a:lstStyle/>
-          <a:p>
-            <a:pPr algn="l" indent="0" marL="0">
-              <a:lnSpc>
-                <a:spcPts val="1620"/>
-              </a:lnSpc>
-              <a:buNone/>
-            </a:pPr>
-            <a:r>
-              <a:rPr lang="en-US" sz="1350" b="1" spc="-10" kern="0" dirty="0">
-                <a:solidFill>
-                  <a:srgbClr val="0A0A0A"/>
-                </a:solidFill>
-                <a:latin typeface="Geist" pitchFamily="34" charset="0"/>
-                <a:ea typeface="Geist" pitchFamily="34" charset="-122"/>
-                <a:cs typeface="Geist" pitchFamily="34" charset="-120"/>
-              </a:rPr>
-              <a:t>знакомые всё равно поехали</a:t>
-            </a:r>
-            <a:endParaRPr lang="en-US" sz="1350" dirty="0"/>
-          </a:p>
-        </p:txBody>
-      </p:sp>
-      <p:sp>
-        <p:nvSpPr>
-          <p:cNvPr id="25" name="text-24"/>
-          <p:cNvSpPr txBox="1"/>
-          <p:nvPr/>
-        </p:nvSpPr>
-        <p:spPr>
-          <a:xfrm rot="-240000">
-            <a:off x="508843" y="3554809"/>
-            <a:ext cx="1278890" cy="514350"/>
-          </a:xfrm>
-          <a:prstGeom prst="rect">
-            <a:avLst/>
-          </a:prstGeom>
-          <a:noFill/>
-          <a:ln/>
-        </p:spPr>
-        <p:txBody>
-          <a:bodyPr wrap="square" lIns="0" tIns="0" rIns="0" bIns="0" rtlCol="0" anchor="t"/>
-          <a:lstStyle/>
-          <a:p>
-            <a:pPr algn="l" indent="0" marL="0">
-              <a:lnSpc>
-                <a:spcPts val="2020"/>
-              </a:lnSpc>
-              <a:buNone/>
-            </a:pPr>
-            <a:r>
-              <a:rPr lang="en-US" sz="1800" i="1" dirty="0">
-                <a:solidFill>
-                  <a:srgbClr val="0A0A0A"/>
-                </a:solidFill>
-                <a:latin typeface="Noto Serif Display Light" pitchFamily="34" charset="0"/>
-                <a:ea typeface="Noto Serif Display Light" pitchFamily="34" charset="-122"/>
-                <a:cs typeface="Noto Serif Display Light" pitchFamily="34" charset="-120"/>
-              </a:rPr>
-              <a:t>и это</a:t>
-            </a:r>
-            <a:endParaRPr lang="en-US" sz="1800" dirty="0"/>
-          </a:p>
-          <a:p>
-            <a:pPr algn="l" indent="0" marL="0">
-              <a:lnSpc>
-                <a:spcPts val="2020"/>
-              </a:lnSpc>
-              <a:buNone/>
-            </a:pPr>
-            <a:r>
-              <a:rPr lang="en-US" sz="1800" i="1" dirty="0">
-                <a:solidFill>
-                  <a:srgbClr val="0A0A0A"/>
-                </a:solidFill>
-                <a:latin typeface="Noto Serif Display Light" pitchFamily="34" charset="0"/>
-                <a:ea typeface="Noto Serif Display Light" pitchFamily="34" charset="-122"/>
-                <a:cs typeface="Noto Serif Display Light" pitchFamily="34" charset="-120"/>
-              </a:rPr>
-              <a:t>нормально</a:t>
-            </a:r>
-            <a:endParaRPr lang="en-US" sz="1800" dirty="0"/>
-          </a:p>
-        </p:txBody>
-      </p:sp>
-      <p:sp>
-        <p:nvSpPr>
-          <p:cNvPr id="26" name="shape-25"/>
-          <p:cNvSpPr/>
-          <p:nvPr/>
-        </p:nvSpPr>
-        <p:spPr>
-          <a:xfrm rot="-360000">
-            <a:off x="3289300" y="2984500"/>
-            <a:ext cx="584200" cy="584200"/>
-          </a:xfrm>
-          <a:prstGeom prst="ellipse">
-            <a:avLst/>
-          </a:prstGeom>
-          <a:solidFill>
-            <a:srgbClr val="57068C"/>
-          </a:solidFill>
-          <a:ln/>
-          <a:effectLst>
-            <a:outerShdw sx="100000" sy="100000" kx="0" ky="0" algn="bl" rotWithShape="0" blurRad="177800" dist="76200" dir="5400000">
-              <a:srgbClr val="000000">
-                <a:alpha val="22000"/>
-              </a:srgbClr>
-            </a:outerShdw>
-          </a:effectLst>
-        </p:spPr>
-      </p:sp>
-      <p:pic>
-        <p:nvPicPr>
-          <p:cNvPr id="27" name="svg-26" descr="preencoded.png">    </p:cNvPr>
+          <p:cNvPr id="26" name="svg-25" descr="preencoded.png">    </p:cNvPr>
           <p:cNvPicPr>
             <a:picLocks noChangeAspect="1"/>
           </p:cNvPicPr>
@@ -5566,15 +5524,57 @@
           </a:stretch>
         </p:blipFill>
         <p:spPr>
-          <a:xfrm rot="-360000">
-            <a:off x="3435350" y="3130550"/>
-            <a:ext cx="292100" cy="292100"/>
+          <a:xfrm rot="360000">
+            <a:off x="3619897" y="929199"/>
+            <a:ext cx="177800" cy="177800"/>
           </a:xfrm>
           <a:prstGeom prst="rect">
             <a:avLst/>
           </a:prstGeom>
         </p:spPr>
       </p:pic>
+      <p:sp>
+        <p:nvSpPr>
+          <p:cNvPr id="27" name="text-26"/>
+          <p:cNvSpPr txBox="1"/>
+          <p:nvPr/>
+        </p:nvSpPr>
+        <p:spPr>
+          <a:xfrm rot="360000">
+            <a:off x="3866305" y="1054675"/>
+            <a:ext cx="2645283" cy="222250"/>
+          </a:xfrm>
+          <a:prstGeom prst="rect">
+            <a:avLst/>
+          </a:prstGeom>
+          <a:noFill/>
+          <a:ln/>
+        </p:spPr>
+        <p:txBody>
+          <a:bodyPr wrap="square" lIns="0" tIns="0" rIns="0" bIns="0" rtlCol="0" anchor="t"/>
+          <a:lstStyle/>
+          <a:p>
+            <a:pPr algn="l" indent="0" marL="0">
+              <a:lnSpc>
+                <a:spcPts val="1620"/>
+              </a:lnSpc>
+              <a:buNone/>
+            </a:pPr>
+            <a:r>
+              <a:rPr lang="en-US" sz="1350" b="1" spc="-10" kern="0" dirty="0">
+                <a:solidFill>
+                  <a:srgbClr val="0A0A0A"/>
+                </a:solidFill>
+                <a:latin typeface="Geist" pitchFamily="34" charset="0"/>
+                <a:ea typeface="Geist" pitchFamily="34" charset="-122"/>
+                <a:cs typeface="Geist" pitchFamily="34" charset="-120"/>
+              </a:rPr>
+              <a:t>знакомые всё равно поехали</a:t>
+            </a:r>
+            <a:endParaRPr lang="en-US" sz="1350" dirty="0"/>
+          </a:p>
+        </p:txBody>
+      </p:sp>
     </p:spTree>
   </p:cSld>
   <p:clrMapOvr>
@@ -5785,7 +5785,7 @@
         </p:blipFill>
         <p:spPr>
           <a:xfrm>
-            <a:off x="3810000" y="1206500"/>
+            <a:off x="5461000" y="6223000"/>
             <a:ext cx="254000" cy="254000"/>
           </a:xfrm>
           <a:prstGeom prst="rect">
@@ -5793,9 +5793,258 @@
           </a:prstGeom>
         </p:spPr>
       </p:pic>
+      <p:sp>
+        <p:nvSpPr>
+          <p:cNvPr id="8" name="text-7"/>
+          <p:cNvSpPr txBox="1"/>
+          <p:nvPr/>
+        </p:nvSpPr>
+        <p:spPr>
+          <a:xfrm>
+            <a:off x="457200" y="889000"/>
+            <a:ext cx="6300216" cy="1257300"/>
+          </a:xfrm>
+          <a:prstGeom prst="rect">
+            <a:avLst/>
+          </a:prstGeom>
+          <a:noFill/>
+          <a:ln/>
+        </p:spPr>
+        <p:txBody>
+          <a:bodyPr wrap="square" lIns="0" tIns="0" rIns="0" bIns="0" rtlCol="0" anchor="t"/>
+          <a:lstStyle/>
+          <a:p>
+            <a:pPr algn="l" indent="0" marL="0">
+              <a:lnSpc>
+                <a:spcPts val="4600"/>
+              </a:lnSpc>
+              <a:buNone/>
+            </a:pPr>
+            <a:r>
+              <a:rPr lang="en-US" sz="4600" b="1" spc="-160" kern="0" dirty="0">
+                <a:solidFill>
+                  <a:srgbClr val="0A0A0A"/>
+                </a:solidFill>
+                <a:latin typeface="Geist" pitchFamily="34" charset="0"/>
+                <a:ea typeface="Geist" pitchFamily="34" charset="-122"/>
+                <a:cs typeface="Geist" pitchFamily="34" charset="-120"/>
+              </a:rPr>
+              <a:t>Родители </a:t>
+            </a:r>
+            <a:pPr algn="l" indent="0" marL="0">
+              <a:lnSpc>
+                <a:spcPts val="4600"/>
+              </a:lnSpc>
+              <a:buNone/>
+            </a:pPr>
+            <a:r>
+              <a:rPr lang="en-US" sz="5200" i="1" spc="-100" kern="0" dirty="0">
+                <a:solidFill>
+                  <a:srgbClr val="57068C"/>
+                </a:solidFill>
+                <a:latin typeface="Noto Serif Display Light" pitchFamily="34" charset="0"/>
+                <a:ea typeface="Noto Serif Display Light" pitchFamily="34" charset="-122"/>
+                <a:cs typeface="Noto Serif Display Light" pitchFamily="34" charset="-120"/>
+              </a:rPr>
+              <a:t>переживали</a:t>
+            </a:r>
+            <a:endParaRPr lang="en-US" sz="4600" dirty="0"/>
+          </a:p>
+        </p:txBody>
+      </p:sp>
+      <p:sp>
+        <p:nvSpPr>
+          <p:cNvPr id="9" name="text-8"/>
+          <p:cNvSpPr txBox="1"/>
+          <p:nvPr/>
+        </p:nvSpPr>
+        <p:spPr>
+          <a:xfrm>
+            <a:off x="457845" y="2259806"/>
+            <a:ext cx="6246368" cy="996950"/>
+          </a:xfrm>
+          <a:prstGeom prst="rect">
+            <a:avLst/>
+          </a:prstGeom>
+          <a:noFill/>
+          <a:ln/>
+        </p:spPr>
+        <p:txBody>
+          <a:bodyPr wrap="square" lIns="0" tIns="0" rIns="0" bIns="0" rtlCol="0" anchor="t"/>
+          <a:lstStyle/>
+          <a:p>
+            <a:pPr algn="l" indent="0" marL="0">
+              <a:lnSpc>
+                <a:spcPts val="1960"/>
+              </a:lnSpc>
+              <a:buNone/>
+            </a:pPr>
+            <a:r>
+              <a:rPr lang="en-US" sz="1400" dirty="0">
+                <a:solidFill>
+                  <a:srgbClr val="2B2A27"/>
+                </a:solidFill>
+                <a:latin typeface="Geist" pitchFamily="34" charset="0"/>
+                <a:ea typeface="Geist" pitchFamily="34" charset="-122"/>
+                <a:cs typeface="Geist" pitchFamily="34" charset="-120"/>
+              </a:rPr>
+              <a:t>Мама и папа, братья и женгешки, все родственники и друзья очень боялись за меня. С мамой мы переписывались по 50 раз в день, днём и ночью. Я мог настоять на своём и полететь, но не стал: их спокойствие оказалось для меня важнее.</a:t>
+            </a:r>
+            <a:endParaRPr lang="en-US" sz="1400" dirty="0"/>
+          </a:p>
+        </p:txBody>
+      </p:sp>
+      <p:sp>
+        <p:nvSpPr>
+          <p:cNvPr id="10" name="text-9"/>
+          <p:cNvSpPr txBox="1"/>
+          <p:nvPr/>
+        </p:nvSpPr>
+        <p:spPr>
+          <a:xfrm>
+            <a:off x="457845" y="3343473"/>
+            <a:ext cx="6246368" cy="749300"/>
+          </a:xfrm>
+          <a:prstGeom prst="rect">
+            <a:avLst/>
+          </a:prstGeom>
+          <a:noFill/>
+          <a:ln/>
+        </p:spPr>
+        <p:txBody>
+          <a:bodyPr wrap="square" lIns="0" tIns="0" rIns="0" bIns="0" rtlCol="0" anchor="t"/>
+          <a:lstStyle/>
+          <a:p>
+            <a:pPr algn="l" indent="0" marL="0">
+              <a:lnSpc>
+                <a:spcPts val="1960"/>
+              </a:lnSpc>
+              <a:buNone/>
+            </a:pPr>
+            <a:r>
+              <a:rPr lang="en-US" sz="1400" dirty="0">
+                <a:solidFill>
+                  <a:srgbClr val="2B2A27"/>
+                </a:solidFill>
+                <a:latin typeface="Geist" pitchFamily="34" charset="0"/>
+                <a:ea typeface="Geist" pitchFamily="34" charset="-122"/>
+                <a:cs typeface="Geist" pitchFamily="34" charset="-120"/>
+              </a:rPr>
+              <a:t>Со стороны это выглядит так, будто я просто послушался родителей и отказался от гранта всей своей жизни. Но дочитай до четвёртой причины.</a:t>
+            </a:r>
+            <a:endParaRPr lang="en-US" sz="1400" dirty="0"/>
+          </a:p>
+        </p:txBody>
+      </p:sp>
+      <p:sp>
+        <p:nvSpPr>
+          <p:cNvPr id="11" name="text-10"/>
+          <p:cNvSpPr txBox="1"/>
+          <p:nvPr/>
+        </p:nvSpPr>
+        <p:spPr>
+          <a:xfrm>
+            <a:off x="457845" y="7969250"/>
+            <a:ext cx="895223" cy="171450"/>
+          </a:xfrm>
+          <a:prstGeom prst="rect">
+            <a:avLst/>
+          </a:prstGeom>
+          <a:noFill/>
+          <a:ln/>
+        </p:spPr>
+        <p:txBody>
+          <a:bodyPr wrap="square" lIns="0" tIns="0" rIns="0" bIns="0" rtlCol="0" anchor="t"/>
+          <a:lstStyle/>
+          <a:p>
+            <a:pPr algn="l" indent="0" marL="0">
+              <a:lnSpc>
+                <a:spcPts val="1200"/>
+              </a:lnSpc>
+              <a:buNone/>
+            </a:pPr>
+            <a:r>
+              <a:rPr lang="en-US" sz="1000" spc="140" kern="0" dirty="0">
+                <a:solidFill>
+                  <a:srgbClr val="0A0A0A"/>
+                </a:solidFill>
+                <a:latin typeface="IBM Plex Mono" pitchFamily="34" charset="0"/>
+                <a:ea typeface="IBM Plex Mono" pitchFamily="34" charset="-122"/>
+                <a:cs typeface="IBM Plex Mono" pitchFamily="34" charset="-120"/>
+              </a:rPr>
+              <a:t>@NURZYCOM</a:t>
+            </a:r>
+            <a:endParaRPr lang="en-US" sz="1000" dirty="0"/>
+          </a:p>
+        </p:txBody>
+      </p:sp>
+      <p:sp>
+        <p:nvSpPr>
+          <p:cNvPr id="12" name="shape-11"/>
+          <p:cNvSpPr/>
+          <p:nvPr/>
+        </p:nvSpPr>
+        <p:spPr>
+          <a:xfrm>
+            <a:off x="5340945" y="7893050"/>
+            <a:ext cx="1060450" cy="323850"/>
+          </a:xfrm>
+          <a:prstGeom prst="roundRect">
+            <a:avLst>
+              <a:gd name="adj" fmla="val 50000"/>
+            </a:avLst>
+          </a:prstGeom>
+          <a:solidFill>
+            <a:srgbClr val="0A0A0A"/>
+          </a:solidFill>
+          <a:ln/>
+        </p:spPr>
+      </p:sp>
+      <p:sp>
+        <p:nvSpPr>
+          <p:cNvPr id="13" name="text-12"/>
+          <p:cNvSpPr txBox="1"/>
+          <p:nvPr/>
+        </p:nvSpPr>
+        <p:spPr>
+          <a:xfrm>
+            <a:off x="5480645" y="7969250"/>
+            <a:ext cx="599059" cy="171450"/>
+          </a:xfrm>
+          <a:prstGeom prst="rect">
+            <a:avLst/>
+          </a:prstGeom>
+          <a:noFill/>
+          <a:ln/>
+        </p:spPr>
+        <p:txBody>
+          <a:bodyPr wrap="square" lIns="0" tIns="0" rIns="0" bIns="0" rtlCol="0" anchor="t"/>
+          <a:lstStyle/>
+          <a:p>
+            <a:pPr algn="l" indent="0" marL="0">
+              <a:lnSpc>
+                <a:spcPts val="1200"/>
+              </a:lnSpc>
+              <a:buNone/>
+            </a:pPr>
+            <a:r>
+              <a:rPr lang="en-US" sz="1000" spc="140" kern="0" dirty="0">
+                <a:solidFill>
+                  <a:srgbClr val="FAF8F3"/>
+                </a:solidFill>
+                <a:latin typeface="IBM Plex Mono" pitchFamily="34" charset="0"/>
+                <a:ea typeface="IBM Plex Mono" pitchFamily="34" charset="-122"/>
+                <a:cs typeface="IBM Plex Mono" pitchFamily="34" charset="-120"/>
+              </a:rPr>
+              <a:t>ЛИСТАЙ</a:t>
+            </a:r>
+            <a:endParaRPr lang="en-US" sz="1000" dirty="0"/>
+          </a:p>
+        </p:txBody>
+      </p:sp>
       <p:pic>
         <p:nvPicPr>
-          <p:cNvPr id="8" name="svg-7" descr="preencoded.png">    </p:cNvPr>
+          <p:cNvPr id="14" name="svg-13" descr="preencoded.png">    </p:cNvPr>
           <p:cNvPicPr>
             <a:picLocks noChangeAspect="1"/>
           </p:cNvPicPr>
@@ -5809,8 +6058,8 @@
         </p:blipFill>
         <p:spPr>
           <a:xfrm>
-            <a:off x="4000500" y="5461000"/>
-            <a:ext cx="190500" cy="190500"/>
+            <a:off x="6121400" y="7985125"/>
+            <a:ext cx="139700" cy="139700"/>
           </a:xfrm>
           <a:prstGeom prst="rect">
             <a:avLst/>
@@ -5819,256 +6068,56 @@
       </p:pic>
       <p:sp>
         <p:nvSpPr>
-          <p:cNvPr id="9" name="text-8"/>
-          <p:cNvSpPr txBox="1"/>
-          <p:nvPr/>
-        </p:nvSpPr>
-        <p:spPr>
-          <a:xfrm>
-            <a:off x="457200" y="889000"/>
-            <a:ext cx="6300216" cy="1257300"/>
-          </a:xfrm>
-          <a:prstGeom prst="rect">
-            <a:avLst/>
-          </a:prstGeom>
-          <a:noFill/>
-          <a:ln/>
-        </p:spPr>
-        <p:txBody>
-          <a:bodyPr wrap="square" lIns="0" tIns="0" rIns="0" bIns="0" rtlCol="0" anchor="t"/>
-          <a:lstStyle/>
-          <a:p>
-            <a:pPr algn="l" indent="0" marL="0">
-              <a:lnSpc>
-                <a:spcPts val="4600"/>
-              </a:lnSpc>
-              <a:buNone/>
-            </a:pPr>
-            <a:r>
-              <a:rPr lang="en-US" sz="4600" b="1" spc="-160" kern="0" dirty="0">
-                <a:solidFill>
-                  <a:srgbClr val="0A0A0A"/>
-                </a:solidFill>
-                <a:latin typeface="Geist" pitchFamily="34" charset="0"/>
-                <a:ea typeface="Geist" pitchFamily="34" charset="-122"/>
-                <a:cs typeface="Geist" pitchFamily="34" charset="-120"/>
-              </a:rPr>
-              <a:t>Родители </a:t>
-            </a:r>
-            <a:pPr algn="l" indent="0" marL="0">
-              <a:lnSpc>
-                <a:spcPts val="4600"/>
-              </a:lnSpc>
-              <a:buNone/>
-            </a:pPr>
-            <a:r>
-              <a:rPr lang="en-US" sz="5200" i="1" spc="-100" kern="0" dirty="0">
-                <a:solidFill>
-                  <a:srgbClr val="57068C"/>
-                </a:solidFill>
-                <a:latin typeface="Noto Serif Display Light" pitchFamily="34" charset="0"/>
-                <a:ea typeface="Noto Serif Display Light" pitchFamily="34" charset="-122"/>
-                <a:cs typeface="Noto Serif Display Light" pitchFamily="34" charset="-120"/>
-              </a:rPr>
-              <a:t>переживали</a:t>
-            </a:r>
-            <a:endParaRPr lang="en-US" sz="4600" dirty="0"/>
-          </a:p>
-        </p:txBody>
-      </p:sp>
-      <p:sp>
-        <p:nvSpPr>
-          <p:cNvPr id="10" name="text-9"/>
-          <p:cNvSpPr txBox="1"/>
-          <p:nvPr/>
-        </p:nvSpPr>
-        <p:spPr>
-          <a:xfrm>
-            <a:off x="457845" y="2259211"/>
-            <a:ext cx="6246368" cy="749300"/>
-          </a:xfrm>
-          <a:prstGeom prst="rect">
-            <a:avLst/>
-          </a:prstGeom>
-          <a:noFill/>
-          <a:ln/>
-        </p:spPr>
-        <p:txBody>
-          <a:bodyPr wrap="square" lIns="0" tIns="0" rIns="0" bIns="0" rtlCol="0" anchor="t"/>
-          <a:lstStyle/>
-          <a:p>
-            <a:pPr algn="l" indent="0" marL="0">
-              <a:lnSpc>
-                <a:spcPts val="1960"/>
-              </a:lnSpc>
-              <a:buNone/>
-            </a:pPr>
-            <a:r>
-              <a:rPr lang="en-US" sz="1400" dirty="0">
-                <a:solidFill>
-                  <a:srgbClr val="2B2A27"/>
-                </a:solidFill>
-                <a:latin typeface="Geist" pitchFamily="34" charset="0"/>
-                <a:ea typeface="Geist" pitchFamily="34" charset="-122"/>
-                <a:cs typeface="Geist" pitchFamily="34" charset="-120"/>
-              </a:rPr>
-              <a:t>Мама и папа, братья и женгешки, все родственники и друзья очень боялись за меня. Я мог настоять на своём и полететь, но не стал: их спокойствие оказалось для меня важнее.</a:t>
-            </a:r>
-            <a:endParaRPr lang="en-US" sz="1400" dirty="0"/>
-          </a:p>
-        </p:txBody>
-      </p:sp>
-      <p:sp>
-        <p:nvSpPr>
-          <p:cNvPr id="11" name="text-10"/>
-          <p:cNvSpPr txBox="1"/>
-          <p:nvPr/>
-        </p:nvSpPr>
-        <p:spPr>
-          <a:xfrm>
-            <a:off x="457845" y="3094633"/>
-            <a:ext cx="6246368" cy="749300"/>
-          </a:xfrm>
-          <a:prstGeom prst="rect">
-            <a:avLst/>
-          </a:prstGeom>
-          <a:noFill/>
-          <a:ln/>
-        </p:spPr>
-        <p:txBody>
-          <a:bodyPr wrap="square" lIns="0" tIns="0" rIns="0" bIns="0" rtlCol="0" anchor="t"/>
-          <a:lstStyle/>
-          <a:p>
-            <a:pPr algn="l" indent="0" marL="0">
-              <a:lnSpc>
-                <a:spcPts val="1960"/>
-              </a:lnSpc>
-              <a:buNone/>
-            </a:pPr>
-            <a:r>
-              <a:rPr lang="en-US" sz="1400" dirty="0">
-                <a:solidFill>
-                  <a:srgbClr val="2B2A27"/>
-                </a:solidFill>
-                <a:latin typeface="Geist" pitchFamily="34" charset="0"/>
-                <a:ea typeface="Geist" pitchFamily="34" charset="-122"/>
-                <a:cs typeface="Geist" pitchFamily="34" charset="-120"/>
-              </a:rPr>
-              <a:t>Со стороны это выглядит так, будто я просто послушался родителей и отказался от гранта всей своей жизни. Но дочитай до четвёртой причины.</a:t>
-            </a:r>
-            <a:endParaRPr lang="en-US" sz="1400" dirty="0"/>
-          </a:p>
-        </p:txBody>
-      </p:sp>
-      <p:sp>
-        <p:nvSpPr>
-          <p:cNvPr id="12" name="text-11"/>
-          <p:cNvSpPr txBox="1"/>
-          <p:nvPr/>
-        </p:nvSpPr>
-        <p:spPr>
-          <a:xfrm>
-            <a:off x="457845" y="7969250"/>
-            <a:ext cx="895223" cy="171450"/>
-          </a:xfrm>
-          <a:prstGeom prst="rect">
-            <a:avLst/>
-          </a:prstGeom>
-          <a:noFill/>
-          <a:ln/>
-        </p:spPr>
-        <p:txBody>
-          <a:bodyPr wrap="square" lIns="0" tIns="0" rIns="0" bIns="0" rtlCol="0" anchor="t"/>
-          <a:lstStyle/>
-          <a:p>
-            <a:pPr algn="l" indent="0" marL="0">
-              <a:lnSpc>
-                <a:spcPts val="1200"/>
-              </a:lnSpc>
-              <a:buNone/>
-            </a:pPr>
-            <a:r>
-              <a:rPr lang="en-US" sz="1000" spc="140" kern="0" dirty="0">
-                <a:solidFill>
-                  <a:srgbClr val="0A0A0A"/>
-                </a:solidFill>
-                <a:latin typeface="IBM Plex Mono" pitchFamily="34" charset="0"/>
-                <a:ea typeface="IBM Plex Mono" pitchFamily="34" charset="-122"/>
-                <a:cs typeface="IBM Plex Mono" pitchFamily="34" charset="-120"/>
-              </a:rPr>
-              <a:t>@NURZYCOM</a:t>
-            </a:r>
-            <a:endParaRPr lang="en-US" sz="1000" dirty="0"/>
-          </a:p>
-        </p:txBody>
-      </p:sp>
-      <p:sp>
-        <p:nvSpPr>
-          <p:cNvPr id="13" name="shape-12"/>
+          <p:cNvPr id="15" name="shape-14"/>
           <p:cNvSpPr/>
           <p:nvPr/>
         </p:nvSpPr>
         <p:spPr>
-          <a:xfrm>
-            <a:off x="5340945" y="7893050"/>
-            <a:ext cx="1060450" cy="323850"/>
-          </a:xfrm>
-          <a:prstGeom prst="roundRect">
-            <a:avLst>
-              <a:gd name="adj" fmla="val 50000"/>
-            </a:avLst>
+          <a:xfrm rot="-120000">
+            <a:off x="381000" y="4127500"/>
+            <a:ext cx="4318000" cy="2457450"/>
+          </a:xfrm>
+          <a:prstGeom prst="rect">
+            <a:avLst/>
           </a:prstGeom>
           <a:solidFill>
-            <a:srgbClr val="0A0A0A"/>
+            <a:srgbClr val="FFFFFF"/>
           </a:solidFill>
           <a:ln/>
-        </p:spPr>
-      </p:sp>
-      <p:sp>
-        <p:nvSpPr>
-          <p:cNvPr id="14" name="text-13"/>
-          <p:cNvSpPr txBox="1"/>
-          <p:nvPr/>
-        </p:nvSpPr>
-        <p:spPr>
-          <a:xfrm>
-            <a:off x="5480645" y="7969250"/>
-            <a:ext cx="599059" cy="171450"/>
-          </a:xfrm>
-          <a:prstGeom prst="rect">
-            <a:avLst/>
-          </a:prstGeom>
-          <a:noFill/>
-          <a:ln/>
-        </p:spPr>
-        <p:txBody>
-          <a:bodyPr wrap="square" lIns="0" tIns="0" rIns="0" bIns="0" rtlCol="0" anchor="t"/>
-          <a:lstStyle/>
-          <a:p>
-            <a:pPr algn="l" indent="0" marL="0">
-              <a:lnSpc>
-                <a:spcPts val="1200"/>
-              </a:lnSpc>
-              <a:buNone/>
-            </a:pPr>
-            <a:r>
-              <a:rPr lang="en-US" sz="1000" spc="140" kern="0" dirty="0">
-                <a:solidFill>
-                  <a:srgbClr val="FAF8F3"/>
-                </a:solidFill>
-                <a:latin typeface="IBM Plex Mono" pitchFamily="34" charset="0"/>
-                <a:ea typeface="IBM Plex Mono" pitchFamily="34" charset="-122"/>
-                <a:cs typeface="IBM Plex Mono" pitchFamily="34" charset="-120"/>
-              </a:rPr>
-              <a:t>ЛИСТАЙ</a:t>
-            </a:r>
-            <a:endParaRPr lang="en-US" sz="1000" dirty="0"/>
-          </a:p>
-        </p:txBody>
+          <a:effectLst>
+            <a:outerShdw sx="100000" sy="100000" kx="0" ky="0" algn="bl" rotWithShape="0" blurRad="177800" dist="76200" dir="5400000">
+              <a:srgbClr val="000000">
+                <a:alpha val="22000"/>
+              </a:srgbClr>
+            </a:outerShdw>
+          </a:effectLst>
+        </p:spPr>
+      </p:sp>
+      <p:sp>
+        <p:nvSpPr>
+          <p:cNvPr id="16" name="shape-15"/>
+          <p:cNvSpPr/>
+          <p:nvPr/>
+        </p:nvSpPr>
+        <p:spPr>
+          <a:xfrm rot="-300000">
+            <a:off x="2085255" y="4026633"/>
+            <a:ext cx="825500" cy="254000"/>
+          </a:xfrm>
+          <a:prstGeom prst="rect">
+            <a:avLst/>
+          </a:prstGeom>
+          <a:solidFill>
+            <a:srgbClr val="D5D5D4">
+              <a:alpha val="90000"/>
+            </a:srgbClr>
+          </a:solidFill>
+          <a:ln/>
+        </p:spPr>
       </p:sp>
       <p:pic>
         <p:nvPicPr>
-          <p:cNvPr id="15" name="svg-14" descr="preencoded.png">    </p:cNvPr>
+          <p:cNvPr id="17" name="img-16" descr="preencoded.png">    </p:cNvPr>
           <p:cNvPicPr>
             <a:picLocks noChangeAspect="1"/>
           </p:cNvPicPr>
@@ -6081,9 +6130,9 @@
           </a:stretch>
         </p:blipFill>
         <p:spPr>
-          <a:xfrm>
-            <a:off x="6121400" y="7985125"/>
-            <a:ext cx="139700" cy="139700"/>
+          <a:xfrm rot="-120000">
+            <a:off x="465024" y="4216485"/>
+            <a:ext cx="4140200" cy="2000250"/>
           </a:xfrm>
           <a:prstGeom prst="rect">
             <a:avLst/>
@@ -6092,20 +6141,64 @@
       </p:pic>
       <p:sp>
         <p:nvSpPr>
-          <p:cNvPr id="16" name="shape-15"/>
+          <p:cNvPr id="18" name="text-17"/>
+          <p:cNvSpPr txBox="1"/>
+          <p:nvPr/>
+        </p:nvSpPr>
+        <p:spPr>
+          <a:xfrm rot="-120000">
+            <a:off x="330320" y="6247777"/>
+            <a:ext cx="4490720" cy="260350"/>
+          </a:xfrm>
+          <a:prstGeom prst="rect">
+            <a:avLst/>
+          </a:prstGeom>
+          <a:noFill/>
+          <a:ln/>
+        </p:spPr>
+        <p:txBody>
+          <a:bodyPr wrap="square" lIns="0" tIns="0" rIns="0" bIns="0" rtlCol="0" anchor="t"/>
+          <a:lstStyle/>
+          <a:p>
+            <a:pPr algn="ctr" indent="0" marL="0">
+              <a:lnSpc>
+                <a:spcPts val="1800"/>
+              </a:lnSpc>
+              <a:buNone/>
+            </a:pPr>
+            <a:r>
+              <a:rPr lang="en-US" sz="1500" i="1" dirty="0">
+                <a:solidFill>
+                  <a:srgbClr val="0A0A0A"/>
+                </a:solidFill>
+                <a:latin typeface="Noto Serif Display Light" pitchFamily="34" charset="0"/>
+                <a:ea typeface="Noto Serif Display Light" pitchFamily="34" charset="-122"/>
+                <a:cs typeface="Noto Serif Display Light" pitchFamily="34" charset="-120"/>
+              </a:rPr>
+              <a:t>переписка с мамой</a:t>
+            </a:r>
+            <a:endParaRPr lang="en-US" sz="1500" dirty="0"/>
+          </a:p>
+        </p:txBody>
+      </p:sp>
+      <p:sp>
+        <p:nvSpPr>
+          <p:cNvPr id="19" name="shape-18"/>
           <p:cNvSpPr/>
           <p:nvPr/>
         </p:nvSpPr>
         <p:spPr>
           <a:xfrm rot="-240000">
-            <a:off x="508000" y="4127500"/>
-            <a:ext cx="2984500" cy="3556000"/>
-          </a:xfrm>
-          <a:prstGeom prst="rect">
-            <a:avLst/>
+            <a:off x="445046" y="6858000"/>
+            <a:ext cx="2165350" cy="374650"/>
+          </a:xfrm>
+          <a:prstGeom prst="roundRect">
+            <a:avLst>
+              <a:gd name="adj" fmla="val 50000"/>
+            </a:avLst>
           </a:prstGeom>
           <a:solidFill>
-            <a:srgbClr val="FFFFFF"/>
+            <a:srgbClr val="57068C"/>
           </a:solidFill>
           <a:ln/>
           <a:effectLst>
@@ -6117,99 +6210,6 @@
           </a:effectLst>
         </p:spPr>
       </p:sp>
-      <p:sp>
-        <p:nvSpPr>
-          <p:cNvPr id="17" name="shape-16"/>
-          <p:cNvSpPr/>
-          <p:nvPr/>
-        </p:nvSpPr>
-        <p:spPr>
-          <a:xfrm rot="-420000">
-            <a:off x="1465245" y="4030169"/>
-            <a:ext cx="825500" cy="254000"/>
-          </a:xfrm>
-          <a:prstGeom prst="rect">
-            <a:avLst/>
-          </a:prstGeom>
-          <a:solidFill>
-            <a:srgbClr val="D5D5D4">
-              <a:alpha val="90000"/>
-            </a:srgbClr>
-          </a:solidFill>
-          <a:ln/>
-        </p:spPr>
-      </p:sp>
-      <p:sp>
-        <p:nvSpPr>
-          <p:cNvPr id="18" name="text-17"/>
-          <p:cNvSpPr txBox="1"/>
-          <p:nvPr/>
-        </p:nvSpPr>
-        <p:spPr>
-          <a:xfrm rot="-240000">
-            <a:off x="1035666" y="4000813"/>
-            <a:ext cx="2026031" cy="3556000"/>
-          </a:xfrm>
-          <a:prstGeom prst="rect">
-            <a:avLst/>
-          </a:prstGeom>
-          <a:noFill/>
-          <a:ln/>
-        </p:spPr>
-        <p:txBody>
-          <a:bodyPr wrap="square" lIns="0" tIns="0" rIns="0" bIns="0" rtlCol="0" anchor="t"/>
-          <a:lstStyle/>
-          <a:p>
-            <a:pPr algn="l" indent="0" marL="0">
-              <a:lnSpc>
-                <a:spcPts val="28000"/>
-              </a:lnSpc>
-              <a:buNone/>
-            </a:pPr>
-            <a:r>
-              <a:rPr lang="en-US" sz="28000" i="1" dirty="0">
-                <a:solidFill>
-                  <a:srgbClr val="0A0A0A"/>
-                </a:solidFill>
-                <a:latin typeface="Noto Serif Display Light" pitchFamily="34" charset="0"/>
-                <a:ea typeface="Noto Serif Display Light" pitchFamily="34" charset="-122"/>
-                <a:cs typeface="Noto Serif Display Light" pitchFamily="34" charset="-120"/>
-              </a:rPr>
-              <a:t>2</a:t>
-            </a:r>
-            <a:endParaRPr lang="en-US" sz="28000" dirty="0"/>
-          </a:p>
-        </p:txBody>
-      </p:sp>
-      <p:sp>
-        <p:nvSpPr>
-          <p:cNvPr id="19" name="shape-18"/>
-          <p:cNvSpPr/>
-          <p:nvPr/>
-        </p:nvSpPr>
-        <p:spPr>
-          <a:xfrm rot="300000">
-            <a:off x="4311104" y="5213350"/>
-            <a:ext cx="2165350" cy="374650"/>
-          </a:xfrm>
-          <a:prstGeom prst="roundRect">
-            <a:avLst>
-              <a:gd name="adj" fmla="val 50000"/>
-            </a:avLst>
-          </a:prstGeom>
-          <a:solidFill>
-            <a:srgbClr val="57068C"/>
-          </a:solidFill>
-          <a:ln/>
-          <a:effectLst>
-            <a:outerShdw sx="100000" sy="100000" kx="0" ky="0" algn="bl" rotWithShape="0" blurRad="177800" dist="76200" dir="5400000">
-              <a:srgbClr val="000000">
-                <a:alpha val="22000"/>
-              </a:srgbClr>
-            </a:outerShdw>
-          </a:effectLst>
-        </p:spPr>
-      </p:sp>
       <p:pic>
         <p:nvPicPr>
           <p:cNvPr id="20" name="svg-19" descr="preencoded.png">    </p:cNvPr>
@@ -6225,8 +6225,8 @@
           </a:stretch>
         </p:blipFill>
         <p:spPr>
-          <a:xfrm rot="300000">
-            <a:off x="4440859" y="5236183"/>
+          <a:xfrm rot="-240000">
+            <a:off x="573613" y="7016926"/>
             <a:ext cx="177800" cy="177800"/>
           </a:xfrm>
           <a:prstGeom prst="rect">
@@ -6241,8 +6241,8 @@
           <p:nvPr/>
         </p:nvSpPr>
         <p:spPr>
-          <a:xfrm rot="300000">
-            <a:off x="4691621" y="5300619"/>
+          <a:xfrm rot="-240000">
+            <a:off x="825736" y="6925341"/>
             <a:ext cx="1756791" cy="222250"/>
           </a:xfrm>
           <a:prstGeom prst="rect">
@@ -6283,8 +6283,8 @@
           <p:nvPr/>
         </p:nvSpPr>
         <p:spPr>
-          <a:xfrm rot="-180000">
-            <a:off x="4381550" y="6076950"/>
+          <a:xfrm rot="180000">
+            <a:off x="2666950" y="7302500"/>
             <a:ext cx="1905000" cy="400050"/>
           </a:xfrm>
           <a:prstGeom prst="roundRect">
@@ -6325,8 +6325,8 @@
           </a:stretch>
         </p:blipFill>
         <p:spPr>
-          <a:xfrm rot="-180000">
-            <a:off x="4522291" y="6225958"/>
+          <a:xfrm rot="180000">
+            <a:off x="2807692" y="7375742"/>
             <a:ext cx="177800" cy="177800"/>
           </a:xfrm>
           <a:prstGeom prst="rect">
@@ -6341,8 +6341,8 @@
           <p:nvPr/>
         </p:nvSpPr>
         <p:spPr>
-          <a:xfrm rot="-180000">
-            <a:off x="4775076" y="6159203"/>
+          <a:xfrm rot="180000">
+            <a:off x="3060476" y="7398046"/>
             <a:ext cx="1453896" cy="222250"/>
           </a:xfrm>
           <a:prstGeom prst="rect">
@@ -6384,8 +6384,8 @@
         </p:nvSpPr>
         <p:spPr>
           <a:xfrm rot="-240000">
-            <a:off x="4828397" y="6979841"/>
-            <a:ext cx="1521206" cy="514350"/>
+            <a:off x="4921643" y="4824809"/>
+            <a:ext cx="1554861" cy="514350"/>
           </a:xfrm>
           <a:prstGeom prst="rect">
             <a:avLst/>
@@ -6412,7 +6412,7 @@
                 <a:ea typeface="Noto Serif Display Light" pitchFamily="34" charset="-122"/>
                 <a:cs typeface="Noto Serif Display Light" pitchFamily="34" charset="-120"/>
               </a:rPr>
-              <a:t>дочитай</a:t>
+              <a:t>50 сообщений</a:t>
             </a:r>
             <a:endParaRPr lang="en-US" sz="1800" dirty="0"/>
           </a:p>
@@ -6432,7 +6432,7 @@
                 <a:ea typeface="Noto Serif Display Light" pitchFamily="34" charset="-122"/>
                 <a:cs typeface="Noto Serif Display Light" pitchFamily="34" charset="-120"/>
               </a:rPr>
-              <a:t>до причины 4</a:t>
+              <a:t>в день</a:t>
             </a:r>
             <a:endParaRPr lang="en-US" sz="1800" dirty="0"/>
           </a:p>
@@ -6446,7 +6446,7 @@
         </p:nvSpPr>
         <p:spPr>
           <a:xfrm rot="-360000">
-            <a:off x="2984500" y="4051300"/>
+            <a:off x="4381500" y="3873500"/>
             <a:ext cx="584200" cy="584200"/>
           </a:xfrm>
           <a:prstGeom prst="ellipse">
@@ -6481,7 +6481,7 @@
         </p:blipFill>
         <p:spPr>
           <a:xfrm rot="-360000">
-            <a:off x="3130550" y="4197350"/>
+            <a:off x="4527550" y="4019550"/>
             <a:ext cx="292100" cy="292100"/>
           </a:xfrm>
           <a:prstGeom prst="rect">
@@ -6699,7 +6699,7 @@
         </p:blipFill>
         <p:spPr>
           <a:xfrm>
-            <a:off x="889000" y="1079500"/>
+            <a:off x="5715000" y="1079500"/>
             <a:ext cx="254000" cy="254000"/>
           </a:xfrm>
           <a:prstGeom prst="rect">
@@ -6723,7 +6723,7 @@
         </p:blipFill>
         <p:spPr>
           <a:xfrm>
-            <a:off x="2984500" y="4381500"/>
+            <a:off x="1270000" y="7302500"/>
             <a:ext cx="190500" cy="190500"/>
           </a:xfrm>
           <a:prstGeom prst="rect">
@@ -6739,8 +6739,8 @@
         </p:nvSpPr>
         <p:spPr>
           <a:xfrm>
-            <a:off x="457200" y="5499497"/>
-            <a:ext cx="6300216" cy="673100"/>
+            <a:off x="457200" y="1651000"/>
+            <a:ext cx="6300216" cy="1409700"/>
           </a:xfrm>
           <a:prstGeom prst="rect">
             <a:avLst/>
@@ -6754,12 +6754,12 @@
           <a:p>
             <a:pPr algn="l" indent="0" marL="0">
               <a:lnSpc>
-                <a:spcPts val="4600"/>
-              </a:lnSpc>
-              <a:buNone/>
-            </a:pPr>
-            <a:r>
-              <a:rPr lang="en-US" sz="4600" b="1" spc="-160" kern="0" dirty="0">
+                <a:spcPts val="5200"/>
+              </a:lnSpc>
+              <a:buNone/>
+            </a:pPr>
+            <a:r>
+              <a:rPr lang="en-US" sz="5200" b="1" spc="-180" kern="0" dirty="0">
                 <a:solidFill>
                   <a:srgbClr val="0A0A0A"/>
                 </a:solidFill>
@@ -6771,12 +6771,12 @@
             </a:r>
             <a:pPr algn="l" indent="0" marL="0">
               <a:lnSpc>
-                <a:spcPts val="4600"/>
-              </a:lnSpc>
-              <a:buNone/>
-            </a:pPr>
-            <a:r>
-              <a:rPr lang="en-US" sz="5200" i="1" spc="-100" kern="0" dirty="0">
+                <a:spcPts val="5200"/>
+              </a:lnSpc>
+              <a:buNone/>
+            </a:pPr>
+            <a:r>
+              <a:rPr lang="en-US" sz="5800" i="1" spc="-120" kern="0" dirty="0">
                 <a:solidFill>
                   <a:srgbClr val="57068C"/>
                 </a:solidFill>
@@ -6786,7 +6786,7 @@
               </a:rPr>
               <a:t>себя</a:t>
             </a:r>
-            <a:endParaRPr lang="en-US" sz="4600" dirty="0"/>
+            <a:endParaRPr lang="en-US" sz="5200" dirty="0"/>
           </a:p>
         </p:txBody>
       </p:sp>
@@ -6798,8 +6798,8 @@
         </p:nvSpPr>
         <p:spPr>
           <a:xfrm>
-            <a:off x="457845" y="6288088"/>
-            <a:ext cx="6246368" cy="495300"/>
+            <a:off x="456059" y="3201392"/>
+            <a:ext cx="5714619" cy="863600"/>
           </a:xfrm>
           <a:prstGeom prst="rect">
             <a:avLst/>
@@ -6813,12 +6813,12 @@
           <a:p>
             <a:pPr algn="l" indent="0" marL="0">
               <a:lnSpc>
-                <a:spcPts val="1960"/>
-              </a:lnSpc>
-              <a:buNone/>
-            </a:pPr>
-            <a:r>
-              <a:rPr lang="en-US" sz="1400" dirty="0">
+                <a:spcPts val="2270"/>
+              </a:lnSpc>
+              <a:buNone/>
+            </a:pPr>
+            <a:r>
+              <a:rPr lang="en-US" sz="1600" dirty="0">
                 <a:solidFill>
                   <a:srgbClr val="2B2A27"/>
                 </a:solidFill>
@@ -6830,12 +6830,12 @@
             </a:r>
             <a:pPr algn="l" indent="0" marL="0">
               <a:lnSpc>
-                <a:spcPts val="1960"/>
-              </a:lnSpc>
-              <a:buNone/>
-            </a:pPr>
-            <a:r>
-              <a:rPr lang="en-US" sz="1400" b="1" dirty="0">
+                <a:spcPts val="2270"/>
+              </a:lnSpc>
+              <a:buNone/>
+            </a:pPr>
+            <a:r>
+              <a:rPr lang="en-US" sz="1600" b="1" dirty="0">
                 <a:solidFill>
                   <a:srgbClr val="0A0A0A"/>
                 </a:solidFill>
@@ -6847,12 +6847,12 @@
             </a:r>
             <a:pPr algn="l" indent="0" marL="0">
               <a:lnSpc>
-                <a:spcPts val="1960"/>
-              </a:lnSpc>
-              <a:buNone/>
-            </a:pPr>
-            <a:r>
-              <a:rPr lang="en-US" sz="1400" dirty="0">
+                <a:spcPts val="2270"/>
+              </a:lnSpc>
+              <a:buNone/>
+            </a:pPr>
+            <a:r>
+              <a:rPr lang="en-US" sz="1600" dirty="0">
                 <a:solidFill>
                   <a:srgbClr val="2B2A27"/>
                 </a:solidFill>
@@ -6862,7 +6862,7 @@
               </a:rPr>
               <a:t>.</a:t>
             </a:r>
-            <a:endParaRPr lang="en-US" sz="1400" dirty="0"/>
+            <a:endParaRPr lang="en-US" sz="1600" dirty="0"/>
           </a:p>
         </p:txBody>
       </p:sp>
@@ -6874,8 +6874,8 @@
         </p:nvSpPr>
         <p:spPr>
           <a:xfrm>
-            <a:off x="457845" y="6872089"/>
-            <a:ext cx="6246368" cy="749300"/>
+            <a:off x="456059" y="4204891"/>
+            <a:ext cx="5714619" cy="1155700"/>
           </a:xfrm>
           <a:prstGeom prst="rect">
             <a:avLst/>
@@ -6889,12 +6889,12 @@
           <a:p>
             <a:pPr algn="l" indent="0" marL="0">
               <a:lnSpc>
-                <a:spcPts val="1960"/>
-              </a:lnSpc>
-              <a:buNone/>
-            </a:pPr>
-            <a:r>
-              <a:rPr lang="en-US" sz="1400" dirty="0">
+                <a:spcPts val="2270"/>
+              </a:lnSpc>
+              <a:buNone/>
+            </a:pPr>
+            <a:r>
+              <a:rPr lang="en-US" sz="1600" dirty="0">
                 <a:solidFill>
                   <a:srgbClr val="2B2A27"/>
                 </a:solidFill>
@@ -6904,7 +6904,7 @@
               </a:rPr>
               <a:t>Мне понравились люди и культура. Ребята там классные, живые, необычные. Но представить себя там через четыре года я так и не смог. И жару после карагандинских снегопадов я тоже не полюбил.</a:t>
             </a:r>
-            <a:endParaRPr lang="en-US" sz="1400" dirty="0"/>
+            <a:endParaRPr lang="en-US" sz="1600" dirty="0"/>
           </a:p>
         </p:txBody>
       </p:sp>
@@ -7045,15 +7045,17 @@
           <p:nvPr/>
         </p:nvSpPr>
         <p:spPr>
-          <a:xfrm rot="240000">
-            <a:off x="3302000" y="889000"/>
-            <a:ext cx="2984500" cy="3556000"/>
-          </a:xfrm>
-          <a:prstGeom prst="rect">
-            <a:avLst/>
+          <a:xfrm rot="-240000">
+            <a:off x="458242" y="5715000"/>
+            <a:ext cx="2336800" cy="374650"/>
+          </a:xfrm>
+          <a:prstGeom prst="roundRect">
+            <a:avLst>
+              <a:gd name="adj" fmla="val 50000"/>
+            </a:avLst>
           </a:prstGeom>
           <a:solidFill>
-            <a:srgbClr val="FFFFFF"/>
+            <a:srgbClr val="57068C"/>
           </a:solidFill>
           <a:ln/>
           <a:effectLst>
@@ -7065,102 +7067,9 @@
           </a:effectLst>
         </p:spPr>
       </p:sp>
-      <p:sp>
-        <p:nvSpPr>
-          <p:cNvPr id="17" name="shape-16"/>
-          <p:cNvSpPr/>
-          <p:nvPr/>
-        </p:nvSpPr>
-        <p:spPr>
-          <a:xfrm rot="60000">
-            <a:off x="4503755" y="791669"/>
-            <a:ext cx="825500" cy="254000"/>
-          </a:xfrm>
-          <a:prstGeom prst="rect">
-            <a:avLst/>
-          </a:prstGeom>
-          <a:solidFill>
-            <a:srgbClr val="D5D5D4">
-              <a:alpha val="90000"/>
-            </a:srgbClr>
-          </a:solidFill>
-          <a:ln/>
-        </p:spPr>
-      </p:sp>
-      <p:sp>
-        <p:nvSpPr>
-          <p:cNvPr id="18" name="text-17"/>
-          <p:cNvSpPr txBox="1"/>
-          <p:nvPr/>
-        </p:nvSpPr>
-        <p:spPr>
-          <a:xfrm rot="240000">
-            <a:off x="3847385" y="762306"/>
-            <a:ext cx="2026031" cy="3556000"/>
-          </a:xfrm>
-          <a:prstGeom prst="rect">
-            <a:avLst/>
-          </a:prstGeom>
-          <a:noFill/>
-          <a:ln/>
-        </p:spPr>
-        <p:txBody>
-          <a:bodyPr wrap="square" lIns="0" tIns="0" rIns="0" bIns="0" rtlCol="0" anchor="t"/>
-          <a:lstStyle/>
-          <a:p>
-            <a:pPr algn="l" indent="0" marL="0">
-              <a:lnSpc>
-                <a:spcPts val="28000"/>
-              </a:lnSpc>
-              <a:buNone/>
-            </a:pPr>
-            <a:r>
-              <a:rPr lang="en-US" sz="28000" i="1" dirty="0">
-                <a:solidFill>
-                  <a:srgbClr val="0A0A0A"/>
-                </a:solidFill>
-                <a:latin typeface="Noto Serif Display Light" pitchFamily="34" charset="0"/>
-                <a:ea typeface="Noto Serif Display Light" pitchFamily="34" charset="-122"/>
-                <a:cs typeface="Noto Serif Display Light" pitchFamily="34" charset="-120"/>
-              </a:rPr>
-              <a:t>3</a:t>
-            </a:r>
-            <a:endParaRPr lang="en-US" sz="28000" dirty="0"/>
-          </a:p>
-        </p:txBody>
-      </p:sp>
-      <p:sp>
-        <p:nvSpPr>
-          <p:cNvPr id="19" name="shape-18"/>
-          <p:cNvSpPr/>
-          <p:nvPr/>
-        </p:nvSpPr>
-        <p:spPr>
-          <a:xfrm rot="-300000">
-            <a:off x="407442" y="1587500"/>
-            <a:ext cx="2336800" cy="374650"/>
-          </a:xfrm>
-          <a:prstGeom prst="roundRect">
-            <a:avLst>
-              <a:gd name="adj" fmla="val 50000"/>
-            </a:avLst>
-          </a:prstGeom>
-          <a:solidFill>
-            <a:srgbClr val="57068C"/>
-          </a:solidFill>
-          <a:ln/>
-          <a:effectLst>
-            <a:outerShdw sx="100000" sy="100000" kx="0" ky="0" algn="bl" rotWithShape="0" blurRad="177800" dist="76200" dir="5400000">
-              <a:srgbClr val="000000">
-                <a:alpha val="22000"/>
-              </a:srgbClr>
-            </a:outerShdw>
-          </a:effectLst>
-        </p:spPr>
-      </p:sp>
       <p:pic>
         <p:nvPicPr>
-          <p:cNvPr id="20" name="svg-19" descr="preencoded.png">    </p:cNvPr>
+          <p:cNvPr id="17" name="svg-16" descr="preencoded.png">    </p:cNvPr>
           <p:cNvPicPr>
             <a:picLocks noChangeAspect="1"/>
           </p:cNvPicPr>
@@ -7173,8 +7082,8 @@
           </a:stretch>
         </p:blipFill>
         <p:spPr>
-          <a:xfrm rot="-300000">
-            <a:off x="537029" y="1769032"/>
+          <a:xfrm rot="-240000">
+            <a:off x="586523" y="5879941"/>
             <a:ext cx="177800" cy="177800"/>
           </a:xfrm>
           <a:prstGeom prst="rect">
@@ -7184,13 +7093,13 @@
       </p:pic>
       <p:sp>
         <p:nvSpPr>
-          <p:cNvPr id="21" name="text-20"/>
+          <p:cNvPr id="18" name="text-17"/>
           <p:cNvSpPr txBox="1"/>
           <p:nvPr/>
         </p:nvSpPr>
         <p:spPr>
-          <a:xfrm rot="-300000">
-            <a:off x="787959" y="1652631"/>
+          <a:xfrm rot="-240000">
+            <a:off x="838932" y="5782341"/>
             <a:ext cx="1938528" cy="222250"/>
           </a:xfrm>
           <a:prstGeom prst="rect">
@@ -7226,13 +7135,13 @@
       </p:sp>
       <p:sp>
         <p:nvSpPr>
-          <p:cNvPr id="22" name="shape-21"/>
+          <p:cNvPr id="19" name="shape-18"/>
           <p:cNvSpPr/>
           <p:nvPr/>
         </p:nvSpPr>
         <p:spPr>
           <a:xfrm rot="180000">
-            <a:off x="634851" y="2540000"/>
+            <a:off x="2285851" y="6286500"/>
             <a:ext cx="1530350" cy="400050"/>
           </a:xfrm>
           <a:prstGeom prst="roundRect">
@@ -7260,7 +7169,7 @@
       </p:sp>
       <p:pic>
         <p:nvPicPr>
-          <p:cNvPr id="23" name="svg-22" descr="preencoded.png">    </p:cNvPr>
+          <p:cNvPr id="20" name="svg-19" descr="preencoded.png">    </p:cNvPr>
           <p:cNvPicPr>
             <a:picLocks noChangeAspect="1"/>
           </p:cNvPicPr>
@@ -7274,7 +7183,7 @@
         </p:blipFill>
         <p:spPr>
           <a:xfrm rot="180000">
-            <a:off x="775435" y="2623051"/>
+            <a:off x="2426435" y="6369551"/>
             <a:ext cx="177800" cy="177800"/>
           </a:xfrm>
           <a:prstGeom prst="rect">
@@ -7284,13 +7193,13 @@
       </p:pic>
       <p:sp>
         <p:nvSpPr>
-          <p:cNvPr id="24" name="text-23"/>
+          <p:cNvPr id="21" name="text-20"/>
           <p:cNvSpPr txBox="1"/>
           <p:nvPr/>
         </p:nvSpPr>
         <p:spPr>
           <a:xfrm rot="180000">
-            <a:off x="1028377" y="2635547"/>
+            <a:off x="2679377" y="6382047"/>
             <a:ext cx="1056767" cy="222250"/>
           </a:xfrm>
           <a:prstGeom prst="rect">
@@ -7326,13 +7235,13 @@
       </p:sp>
       <p:sp>
         <p:nvSpPr>
-          <p:cNvPr id="25" name="text-24"/>
+          <p:cNvPr id="22" name="text-21"/>
           <p:cNvSpPr txBox="1"/>
           <p:nvPr/>
         </p:nvSpPr>
         <p:spPr>
           <a:xfrm rot="-240000">
-            <a:off x="508198" y="3554809"/>
+            <a:off x="4794941" y="6856809"/>
             <a:ext cx="1554861" cy="514350"/>
           </a:xfrm>
           <a:prstGeom prst="rect">
@@ -7345,7 +7254,7 @@
           <a:bodyPr wrap="square" lIns="0" tIns="0" rIns="0" bIns="0" rtlCol="0" anchor="t"/>
           <a:lstStyle/>
           <a:p>
-            <a:pPr algn="l" indent="0" marL="0">
+            <a:pPr algn="r" indent="0" marL="0">
               <a:lnSpc>
                 <a:spcPts val="2020"/>
               </a:lnSpc>
@@ -7365,7 +7274,7 @@
             <a:endParaRPr lang="en-US" sz="1800" dirty="0"/>
           </a:p>
           <a:p>
-            <a:pPr algn="l" indent="0" marL="0">
+            <a:pPr algn="r" indent="0" marL="0">
               <a:lnSpc>
                 <a:spcPts val="2020"/>
               </a:lnSpc>
@@ -7388,13 +7297,13 @@
       </p:sp>
       <p:sp>
         <p:nvSpPr>
-          <p:cNvPr id="26" name="shape-25"/>
+          <p:cNvPr id="23" name="shape-22"/>
           <p:cNvSpPr/>
           <p:nvPr/>
         </p:nvSpPr>
         <p:spPr>
           <a:xfrm rot="-360000">
-            <a:off x="3289300" y="2984500"/>
+            <a:off x="457200" y="952500"/>
             <a:ext cx="584200" cy="584200"/>
           </a:xfrm>
           <a:prstGeom prst="ellipse">
@@ -7415,7 +7324,7 @@
       </p:sp>
       <p:pic>
         <p:nvPicPr>
-          <p:cNvPr id="27" name="svg-26" descr="preencoded.png">    </p:cNvPr>
+          <p:cNvPr id="24" name="svg-23" descr="preencoded.png">    </p:cNvPr>
           <p:cNvPicPr>
             <a:picLocks noChangeAspect="1"/>
           </p:cNvPicPr>
@@ -7429,7 +7338,7 @@
         </p:blipFill>
         <p:spPr>
           <a:xfrm rot="-360000">
-            <a:off x="3435350" y="3130550"/>
+            <a:off x="603250" y="1098550"/>
             <a:ext cx="292100" cy="292100"/>
           </a:xfrm>
           <a:prstGeom prst="rect">
@@ -9444,8 +9353,8 @@
         </p:nvSpPr>
         <p:spPr>
           <a:xfrm>
-            <a:off x="457200" y="952500"/>
-            <a:ext cx="6300216" cy="673100"/>
+            <a:off x="457200" y="2286000"/>
+            <a:ext cx="6300216" cy="749300"/>
           </a:xfrm>
           <a:prstGeom prst="rect">
             <a:avLst/>
@@ -9459,12 +9368,12 @@
           <a:p>
             <a:pPr algn="l" indent="0" marL="0">
               <a:lnSpc>
-                <a:spcPts val="4600"/>
-              </a:lnSpc>
-              <a:buNone/>
-            </a:pPr>
-            <a:r>
-              <a:rPr lang="en-US" sz="4600" b="1" spc="-160" kern="0" dirty="0">
+                <a:spcPts val="5200"/>
+              </a:lnSpc>
+              <a:buNone/>
+            </a:pPr>
+            <a:r>
+              <a:rPr lang="en-US" sz="5200" b="1" spc="-180" kern="0" dirty="0">
                 <a:solidFill>
                   <a:srgbClr val="0A0A0A"/>
                 </a:solidFill>
@@ -9476,12 +9385,12 @@
             </a:r>
             <a:pPr algn="l" indent="0" marL="0">
               <a:lnSpc>
-                <a:spcPts val="4600"/>
-              </a:lnSpc>
-              <a:buNone/>
-            </a:pPr>
-            <a:r>
-              <a:rPr lang="en-US" sz="5200" i="1" spc="-100" kern="0" dirty="0">
+                <a:spcPts val="5200"/>
+              </a:lnSpc>
+              <a:buNone/>
+            </a:pPr>
+            <a:r>
+              <a:rPr lang="en-US" sz="5800" i="1" spc="-120" kern="0" dirty="0">
                 <a:solidFill>
                   <a:srgbClr val="57068C"/>
                 </a:solidFill>
@@ -9491,7 +9400,7 @@
               </a:rPr>
               <a:t>учу</a:t>
             </a:r>
-            <a:endParaRPr lang="en-US" sz="4600" dirty="0"/>
+            <a:endParaRPr lang="en-US" sz="5200" dirty="0"/>
           </a:p>
         </p:txBody>
       </p:sp>
@@ -9503,8 +9412,8 @@
         </p:nvSpPr>
         <p:spPr>
           <a:xfrm>
-            <a:off x="457845" y="1738511"/>
-            <a:ext cx="6246368" cy="749300"/>
+            <a:off x="456059" y="3175992"/>
+            <a:ext cx="5714619" cy="863600"/>
           </a:xfrm>
           <a:prstGeom prst="rect">
             <a:avLst/>
@@ -9518,12 +9427,12 @@
           <a:p>
             <a:pPr algn="l" indent="0" marL="0">
               <a:lnSpc>
-                <a:spcPts val="1960"/>
-              </a:lnSpc>
-              <a:buNone/>
-            </a:pPr>
-            <a:r>
-              <a:rPr lang="en-US" sz="1400" dirty="0">
+                <a:spcPts val="2270"/>
+              </a:lnSpc>
+              <a:buNone/>
+            </a:pPr>
+            <a:r>
+              <a:rPr lang="en-US" sz="1600" dirty="0">
                 <a:solidFill>
                   <a:srgbClr val="2B2A27"/>
                 </a:solidFill>
@@ -9531,15 +9440,125 @@
                 <a:ea typeface="Geist" pitchFamily="34" charset="-122"/>
                 <a:cs typeface="Geist" pitchFamily="34" charset="-120"/>
               </a:rPr>
-              <a:t>Умение учиться самому дало мне больше, чем любой оффер. Этому я учу на занятиях по SAT Verbal и химии, онлайн и без спешки. Начнём с бесплатной консультации.</a:t>
-            </a:r>
-            <a:endParaRPr lang="en-US" sz="1400" dirty="0"/>
+              <a:t>Умение учиться самому дало мне больше, чем любой оффер. Оно помогло мне принять это решение и не жалеть о нём.</a:t>
+            </a:r>
+            <a:endParaRPr lang="en-US" sz="1600" dirty="0"/>
+          </a:p>
+        </p:txBody>
+      </p:sp>
+      <p:sp>
+        <p:nvSpPr>
+          <p:cNvPr id="9" name="text-8"/>
+          <p:cNvSpPr txBox="1"/>
+          <p:nvPr/>
+        </p:nvSpPr>
+        <p:spPr>
+          <a:xfrm>
+            <a:off x="456059" y="4179888"/>
+            <a:ext cx="5714619" cy="577850"/>
+          </a:xfrm>
+          <a:prstGeom prst="rect">
+            <a:avLst/>
+          </a:prstGeom>
+          <a:noFill/>
+          <a:ln/>
+        </p:spPr>
+        <p:txBody>
+          <a:bodyPr wrap="square" lIns="0" tIns="0" rIns="0" bIns="0" rtlCol="0" anchor="t"/>
+          <a:lstStyle/>
+          <a:p>
+            <a:pPr algn="l" indent="0" marL="0">
+              <a:lnSpc>
+                <a:spcPts val="2270"/>
+              </a:lnSpc>
+              <a:buNone/>
+            </a:pPr>
+            <a:r>
+              <a:rPr lang="en-US" sz="1600" dirty="0">
+                <a:solidFill>
+                  <a:srgbClr val="2B2A27"/>
+                </a:solidFill>
+                <a:latin typeface="Geist" pitchFamily="34" charset="0"/>
+                <a:ea typeface="Geist" pitchFamily="34" charset="-122"/>
+                <a:cs typeface="Geist" pitchFamily="34" charset="-120"/>
+              </a:rPr>
+              <a:t>Сейчас я учусь в НУ и преподаю </a:t>
+            </a:r>
+            <a:pPr algn="l" indent="0" marL="0">
+              <a:lnSpc>
+                <a:spcPts val="2270"/>
+              </a:lnSpc>
+              <a:buNone/>
+            </a:pPr>
+            <a:r>
+              <a:rPr lang="en-US" sz="1600" b="1" dirty="0">
+                <a:solidFill>
+                  <a:srgbClr val="0A0A0A"/>
+                </a:solidFill>
+                <a:latin typeface="Geist" pitchFamily="34" charset="0"/>
+                <a:ea typeface="Geist" pitchFamily="34" charset="-122"/>
+                <a:cs typeface="Geist" pitchFamily="34" charset="-120"/>
+              </a:rPr>
+              <a:t>SAT Verbal</a:t>
+            </a:r>
+            <a:pPr algn="l" indent="0" marL="0">
+              <a:lnSpc>
+                <a:spcPts val="2270"/>
+              </a:lnSpc>
+              <a:buNone/>
+            </a:pPr>
+            <a:r>
+              <a:rPr lang="en-US" sz="1600" dirty="0">
+                <a:solidFill>
+                  <a:srgbClr val="2B2A27"/>
+                </a:solidFill>
+                <a:latin typeface="Geist" pitchFamily="34" charset="0"/>
+                <a:ea typeface="Geist" pitchFamily="34" charset="-122"/>
+                <a:cs typeface="Geist" pitchFamily="34" charset="-120"/>
+              </a:rPr>
+              <a:t> и </a:t>
+            </a:r>
+            <a:pPr algn="l" indent="0" marL="0">
+              <a:lnSpc>
+                <a:spcPts val="2270"/>
+              </a:lnSpc>
+              <a:buNone/>
+            </a:pPr>
+            <a:r>
+              <a:rPr lang="en-US" sz="1600" b="1" dirty="0">
+                <a:solidFill>
+                  <a:srgbClr val="0A0A0A"/>
+                </a:solidFill>
+                <a:latin typeface="Geist" pitchFamily="34" charset="0"/>
+                <a:ea typeface="Geist" pitchFamily="34" charset="-122"/>
+                <a:cs typeface="Geist" pitchFamily="34" charset="-120"/>
+              </a:rPr>
+              <a:t>химию</a:t>
+            </a:r>
+            <a:pPr algn="l" indent="0" marL="0">
+              <a:lnSpc>
+                <a:spcPts val="2270"/>
+              </a:lnSpc>
+              <a:buNone/>
+            </a:pPr>
+            <a:r>
+              <a:rPr lang="en-US" sz="1600" dirty="0">
+                <a:solidFill>
+                  <a:srgbClr val="2B2A27"/>
+                </a:solidFill>
+                <a:latin typeface="Geist" pitchFamily="34" charset="0"/>
+                <a:ea typeface="Geist" pitchFamily="34" charset="-122"/>
+                <a:cs typeface="Geist" pitchFamily="34" charset="-120"/>
+              </a:rPr>
+              <a:t>. На занятиях учу тому же: учиться самостоятельно.</a:t>
+            </a:r>
+            <a:endParaRPr lang="en-US" sz="1600" dirty="0"/>
           </a:p>
         </p:txBody>
       </p:sp>
       <p:pic>
         <p:nvPicPr>
-          <p:cNvPr id="9" name="svg-8" descr="preencoded.png">    </p:cNvPr>
+          <p:cNvPr id="10" name="svg-9" descr="preencoded.png">    </p:cNvPr>
           <p:cNvPicPr>
             <a:picLocks noChangeAspect="1"/>
           </p:cNvPicPr>
@@ -9553,7 +9572,7 @@
         </p:blipFill>
         <p:spPr>
           <a:xfrm>
-            <a:off x="3302000" y="3810000"/>
+            <a:off x="5842000" y="1270000"/>
             <a:ext cx="254000" cy="254000"/>
           </a:xfrm>
           <a:prstGeom prst="rect">
@@ -9563,7 +9582,7 @@
       </p:pic>
       <p:pic>
         <p:nvPicPr>
-          <p:cNvPr id="10" name="svg-9" descr="preencoded.png">    </p:cNvPr>
+          <p:cNvPr id="11" name="svg-10" descr="preencoded.png">    </p:cNvPr>
           <p:cNvPicPr>
             <a:picLocks noChangeAspect="1"/>
           </p:cNvPicPr>
@@ -9577,7 +9596,7 @@
         </p:blipFill>
         <p:spPr>
           <a:xfrm>
-            <a:off x="2984500" y="7493000"/>
+            <a:off x="4826000" y="7302500"/>
             <a:ext cx="190500" cy="190500"/>
           </a:xfrm>
           <a:prstGeom prst="rect">
@@ -9587,13 +9606,13 @@
       </p:pic>
       <p:sp>
         <p:nvSpPr>
-          <p:cNvPr id="11" name="text-10"/>
+          <p:cNvPr id="12" name="text-11"/>
           <p:cNvSpPr txBox="1"/>
           <p:nvPr/>
         </p:nvSpPr>
         <p:spPr>
           <a:xfrm>
-            <a:off x="457845" y="7969250"/>
+            <a:off x="457845" y="8045450"/>
             <a:ext cx="895223" cy="171450"/>
           </a:xfrm>
           <a:prstGeom prst="rect">
@@ -9629,334 +9648,13 @@
       </p:sp>
       <p:sp>
         <p:nvSpPr>
-          <p:cNvPr id="12" name="shape-11"/>
+          <p:cNvPr id="13" name="shape-12"/>
           <p:cNvSpPr/>
           <p:nvPr/>
         </p:nvSpPr>
         <p:spPr>
-          <a:xfrm>
-            <a:off x="4711700" y="7893050"/>
-            <a:ext cx="1689100" cy="323850"/>
-          </a:xfrm>
-          <a:prstGeom prst="roundRect">
-            <a:avLst>
-              <a:gd name="adj" fmla="val 50000"/>
-            </a:avLst>
-          </a:prstGeom>
-          <a:solidFill>
-            <a:srgbClr val="0A0A0A"/>
-          </a:solidFill>
-          <a:ln/>
-        </p:spPr>
-      </p:sp>
-      <p:sp>
-        <p:nvSpPr>
-          <p:cNvPr id="13" name="text-12"/>
-          <p:cNvSpPr txBox="1"/>
-          <p:nvPr/>
-        </p:nvSpPr>
-        <p:spPr>
-          <a:xfrm>
-            <a:off x="4851400" y="7969250"/>
-            <a:ext cx="1494282" cy="171450"/>
-          </a:xfrm>
-          <a:prstGeom prst="rect">
-            <a:avLst/>
-          </a:prstGeom>
-          <a:noFill/>
-          <a:ln/>
-        </p:spPr>
-        <p:txBody>
-          <a:bodyPr wrap="square" lIns="0" tIns="0" rIns="0" bIns="0" rtlCol="0" anchor="t"/>
-          <a:lstStyle/>
-          <a:p>
-            <a:pPr algn="l" indent="0" marL="0">
-              <a:lnSpc>
-                <a:spcPts val="1200"/>
-              </a:lnSpc>
-              <a:buNone/>
-            </a:pPr>
-            <a:r>
-              <a:rPr lang="en-US" sz="1000" spc="140" kern="0" dirty="0">
-                <a:solidFill>
-                  <a:srgbClr val="FAF8F3"/>
-                </a:solidFill>
-                <a:latin typeface="IBM Plex Mono" pitchFamily="34" charset="0"/>
-                <a:ea typeface="IBM Plex Mono" pitchFamily="34" charset="-122"/>
-                <a:cs typeface="IBM Plex Mono" pitchFamily="34" charset="-120"/>
-              </a:rPr>
-              <a:t>ПИШИ В TELEGRAM</a:t>
-            </a:r>
-            <a:endParaRPr lang="en-US" sz="1000" dirty="0"/>
-          </a:p>
-        </p:txBody>
-      </p:sp>
-      <p:sp>
-        <p:nvSpPr>
-          <p:cNvPr id="14" name="shape-13"/>
-          <p:cNvSpPr/>
-          <p:nvPr/>
-        </p:nvSpPr>
-        <p:spPr>
-          <a:xfrm rot="480000">
-            <a:off x="5702300" y="3556000"/>
-            <a:ext cx="584200" cy="584200"/>
-          </a:xfrm>
-          <a:prstGeom prst="ellipse">
-            <a:avLst/>
-          </a:prstGeom>
-          <a:solidFill>
-            <a:srgbClr val="FAF8F3"/>
-          </a:solidFill>
-          <a:ln w="19050">
-            <a:solidFill>
-              <a:srgbClr val="57068C"/>
-            </a:solidFill>
-            <a:prstDash val="solid"/>
-          </a:ln>
-          <a:effectLst>
-            <a:outerShdw sx="100000" sy="100000" kx="0" ky="0" algn="bl" rotWithShape="0" blurRad="177800" dist="76200" dir="5400000">
-              <a:srgbClr val="000000">
-                <a:alpha val="22000"/>
-              </a:srgbClr>
-            </a:outerShdw>
-          </a:effectLst>
-        </p:spPr>
-      </p:sp>
-      <p:pic>
-        <p:nvPicPr>
-          <p:cNvPr id="15" name="svg-14" descr="preencoded.png">    </p:cNvPr>
-          <p:cNvPicPr>
-            <a:picLocks noChangeAspect="1"/>
-          </p:cNvPicPr>
-          <p:nvPr/>
-        </p:nvPicPr>
-        <p:blipFill>
-          <a:blip r:embed="rId5"/>
-          <a:stretch>
-            <a:fillRect/>
-          </a:stretch>
-        </p:blipFill>
-        <p:spPr>
-          <a:xfrm rot="480000">
-            <a:off x="5848350" y="3702050"/>
-            <a:ext cx="292100" cy="292100"/>
-          </a:xfrm>
-          <a:prstGeom prst="rect">
-            <a:avLst/>
-          </a:prstGeom>
-        </p:spPr>
-      </p:pic>
-      <p:sp>
-        <p:nvSpPr>
-          <p:cNvPr id="16" name="shape-15"/>
-          <p:cNvSpPr/>
-          <p:nvPr/>
-        </p:nvSpPr>
-        <p:spPr>
-          <a:xfrm rot="-120000">
-            <a:off x="508000" y="4064298"/>
-            <a:ext cx="5842000" cy="2279650"/>
-          </a:xfrm>
-          <a:prstGeom prst="roundRect">
-            <a:avLst>
-              <a:gd name="adj" fmla="val 8357"/>
-            </a:avLst>
-          </a:prstGeom>
-          <a:solidFill>
-            <a:srgbClr val="57068C"/>
-          </a:solidFill>
-          <a:ln/>
-          <a:effectLst>
-            <a:outerShdw sx="100000" sy="100000" kx="0" ky="0" algn="bl" rotWithShape="0" blurRad="177800" dist="76200" dir="5400000">
-              <a:srgbClr val="000000">
-                <a:alpha val="22000"/>
-              </a:srgbClr>
-            </a:outerShdw>
-          </a:effectLst>
-        </p:spPr>
-      </p:sp>
-      <p:sp>
-        <p:nvSpPr>
-          <p:cNvPr id="17" name="text-16"/>
-          <p:cNvSpPr txBox="1"/>
-          <p:nvPr/>
-        </p:nvSpPr>
-        <p:spPr>
-          <a:xfrm rot="-120000">
-            <a:off x="811153" y="4356572"/>
-            <a:ext cx="5492496" cy="146050"/>
-          </a:xfrm>
-          <a:prstGeom prst="rect">
-            <a:avLst/>
-          </a:prstGeom>
-          <a:noFill/>
-          <a:ln/>
-        </p:spPr>
-        <p:txBody>
-          <a:bodyPr wrap="square" lIns="0" tIns="0" rIns="0" bIns="0" rtlCol="0" anchor="t"/>
-          <a:lstStyle/>
-          <a:p>
-            <a:pPr algn="l" indent="0" marL="0">
-              <a:lnSpc>
-                <a:spcPts val="1080"/>
-              </a:lnSpc>
-              <a:buNone/>
-            </a:pPr>
-            <a:r>
-              <a:rPr lang="en-US" sz="900" spc="140" kern="0" dirty="0">
-                <a:solidFill>
-                  <a:srgbClr val="FAF8F3"/>
-                </a:solidFill>
-                <a:latin typeface="IBM Plex Mono" pitchFamily="34" charset="0"/>
-                <a:ea typeface="IBM Plex Mono" pitchFamily="34" charset="-122"/>
-                <a:cs typeface="IBM Plex Mono" pitchFamily="34" charset="-120"/>
-              </a:rPr>
-              <a:t>БЕСПЛАТНО · 20 МИНУТ · ОНЛАЙН</a:t>
-            </a:r>
-            <a:endParaRPr lang="en-US" sz="900" dirty="0"/>
-          </a:p>
-        </p:txBody>
-      </p:sp>
-      <p:sp>
-        <p:nvSpPr>
-          <p:cNvPr id="18" name="text-17"/>
-          <p:cNvSpPr txBox="1"/>
-          <p:nvPr/>
-        </p:nvSpPr>
-        <p:spPr>
-          <a:xfrm rot="-120000">
-            <a:off x="831108" y="4578771"/>
-            <a:ext cx="5492496" cy="844550"/>
-          </a:xfrm>
-          <a:prstGeom prst="rect">
-            <a:avLst/>
-          </a:prstGeom>
-          <a:noFill/>
-          <a:ln/>
-        </p:spPr>
-        <p:txBody>
-          <a:bodyPr wrap="square" lIns="0" tIns="0" rIns="0" bIns="0" rtlCol="0" anchor="t"/>
-          <a:lstStyle/>
-          <a:p>
-            <a:pPr algn="l" indent="0" marL="0">
-              <a:lnSpc>
-                <a:spcPts val="3330"/>
-              </a:lnSpc>
-              <a:buNone/>
-            </a:pPr>
-            <a:r>
-              <a:rPr lang="en-US" sz="3200" i="1" dirty="0">
-                <a:solidFill>
-                  <a:srgbClr val="FAF8F3"/>
-                </a:solidFill>
-                <a:latin typeface="Noto Serif Display Light" pitchFamily="34" charset="0"/>
-                <a:ea typeface="Noto Serif Display Light" pitchFamily="34" charset="-122"/>
-                <a:cs typeface="Noto Serif Display Light" pitchFamily="34" charset="-120"/>
-              </a:rPr>
-              <a:t>20 минут, чтобы понять, с чего начать</a:t>
-            </a:r>
-            <a:endParaRPr lang="en-US" sz="3200" dirty="0"/>
-          </a:p>
-        </p:txBody>
-      </p:sp>
-      <p:sp>
-        <p:nvSpPr>
-          <p:cNvPr id="19" name="shape-18"/>
-          <p:cNvSpPr/>
-          <p:nvPr/>
-        </p:nvSpPr>
-        <p:spPr>
-          <a:xfrm rot="-120000">
-            <a:off x="861987" y="5647790"/>
-            <a:ext cx="1765300" cy="463550"/>
-          </a:xfrm>
-          <a:prstGeom prst="roundRect">
-            <a:avLst>
-              <a:gd name="adj" fmla="val 50000"/>
-            </a:avLst>
-          </a:prstGeom>
-          <a:solidFill>
-            <a:srgbClr val="FAF8F3"/>
-          </a:solidFill>
-          <a:ln/>
-        </p:spPr>
-      </p:sp>
-      <p:pic>
-        <p:nvPicPr>
-          <p:cNvPr id="20" name="svg-19" descr="preencoded.png">    </p:cNvPr>
-          <p:cNvPicPr>
-            <a:picLocks noChangeAspect="1"/>
-          </p:cNvPicPr>
-          <p:nvPr/>
-        </p:nvPicPr>
-        <p:blipFill>
-          <a:blip r:embed="rId6"/>
-          <a:stretch>
-            <a:fillRect/>
-          </a:stretch>
-        </p:blipFill>
-        <p:spPr>
-          <a:xfrm rot="-120000">
-            <a:off x="1026226" y="5806076"/>
-            <a:ext cx="190500" cy="190500"/>
-          </a:xfrm>
-          <a:prstGeom prst="rect">
-            <a:avLst/>
-          </a:prstGeom>
-        </p:spPr>
-      </p:pic>
-      <p:sp>
-        <p:nvSpPr>
-          <p:cNvPr id="21" name="text-20"/>
-          <p:cNvSpPr txBox="1"/>
-          <p:nvPr/>
-        </p:nvSpPr>
-        <p:spPr>
-          <a:xfrm rot="-120000">
-            <a:off x="1293706" y="5744736"/>
-            <a:ext cx="1238504" cy="260350"/>
-          </a:xfrm>
-          <a:prstGeom prst="rect">
-            <a:avLst/>
-          </a:prstGeom>
-          <a:noFill/>
-          <a:ln/>
-        </p:spPr>
-        <p:txBody>
-          <a:bodyPr wrap="square" lIns="0" tIns="0" rIns="0" bIns="0" rtlCol="0" anchor="t"/>
-          <a:lstStyle/>
-          <a:p>
-            <a:pPr algn="l" indent="0" marL="0">
-              <a:lnSpc>
-                <a:spcPts val="1920"/>
-              </a:lnSpc>
-              <a:buNone/>
-            </a:pPr>
-            <a:r>
-              <a:rPr lang="en-US" sz="1600" b="1" dirty="0">
-                <a:solidFill>
-                  <a:srgbClr val="0A0A0A"/>
-                </a:solidFill>
-                <a:latin typeface="Geist" pitchFamily="34" charset="0"/>
-                <a:ea typeface="Geist" pitchFamily="34" charset="-122"/>
-                <a:cs typeface="Geist" pitchFamily="34" charset="-120"/>
-              </a:rPr>
-              <a:t>@nurzycom</a:t>
-            </a:r>
-            <a:endParaRPr lang="en-US" sz="1600" dirty="0"/>
-          </a:p>
-        </p:txBody>
-      </p:sp>
-      <p:sp>
-        <p:nvSpPr>
-          <p:cNvPr id="22" name="shape-21"/>
-          <p:cNvSpPr/>
-          <p:nvPr/>
-        </p:nvSpPr>
-        <p:spPr>
           <a:xfrm rot="-240000">
-            <a:off x="445046" y="6604000"/>
+            <a:off x="457746" y="5842000"/>
             <a:ext cx="1422400" cy="400050"/>
           </a:xfrm>
           <a:prstGeom prst="roundRect">
@@ -9984,21 +9682,21 @@
       </p:sp>
       <p:pic>
         <p:nvPicPr>
-          <p:cNvPr id="23" name="svg-22" descr="preencoded.png">    </p:cNvPr>
+          <p:cNvPr id="14" name="svg-13" descr="preencoded.png">    </p:cNvPr>
           <p:cNvPicPr>
             <a:picLocks noChangeAspect="1"/>
           </p:cNvPicPr>
           <p:nvPr/>
         </p:nvPicPr>
         <p:blipFill>
-          <a:blip r:embed="rId7"/>
+          <a:blip r:embed="rId5"/>
           <a:stretch>
             <a:fillRect/>
           </a:stretch>
         </p:blipFill>
         <p:spPr>
           <a:xfrm rot="-240000">
-            <a:off x="585377" y="6748828"/>
+            <a:off x="598077" y="5986828"/>
             <a:ext cx="177800" cy="177800"/>
           </a:xfrm>
           <a:prstGeom prst="rect">
@@ -10008,13 +9706,13 @@
       </p:pic>
       <p:sp>
         <p:nvSpPr>
-          <p:cNvPr id="24" name="text-23"/>
+          <p:cNvPr id="15" name="text-14"/>
           <p:cNvSpPr txBox="1"/>
           <p:nvPr/>
         </p:nvSpPr>
         <p:spPr>
           <a:xfrm rot="-240000">
-            <a:off x="838436" y="6684041"/>
+            <a:off x="851136" y="5922041"/>
             <a:ext cx="942340" cy="222250"/>
           </a:xfrm>
           <a:prstGeom prst="rect">
@@ -10050,13 +9748,13 @@
       </p:sp>
       <p:sp>
         <p:nvSpPr>
-          <p:cNvPr id="25" name="shape-24"/>
+          <p:cNvPr id="16" name="shape-15"/>
           <p:cNvSpPr/>
           <p:nvPr/>
         </p:nvSpPr>
         <p:spPr>
           <a:xfrm rot="240000">
-            <a:off x="3748038" y="6731000"/>
+            <a:off x="1585962" y="6350000"/>
             <a:ext cx="2667000" cy="400050"/>
           </a:xfrm>
           <a:prstGeom prst="roundRect">
@@ -10084,21 +9782,21 @@
       </p:sp>
       <p:pic>
         <p:nvPicPr>
-          <p:cNvPr id="26" name="svg-25" descr="preencoded.png">    </p:cNvPr>
+          <p:cNvPr id="17" name="svg-16" descr="preencoded.png">    </p:cNvPr>
           <p:cNvPicPr>
             <a:picLocks noChangeAspect="1"/>
           </p:cNvPicPr>
           <p:nvPr/>
         </p:nvPicPr>
         <p:blipFill>
-          <a:blip r:embed="rId8"/>
+          <a:blip r:embed="rId6"/>
           <a:stretch>
             <a:fillRect/>
           </a:stretch>
         </p:blipFill>
         <p:spPr>
           <a:xfrm rot="240000">
-            <a:off x="3891963" y="6765158"/>
+            <a:off x="1729888" y="6384158"/>
             <a:ext cx="177800" cy="177800"/>
           </a:xfrm>
           <a:prstGeom prst="rect">
@@ -10108,13 +9806,13 @@
       </p:pic>
       <p:sp>
         <p:nvSpPr>
-          <p:cNvPr id="27" name="text-26"/>
+          <p:cNvPr id="18" name="text-17"/>
           <p:cNvSpPr txBox="1"/>
           <p:nvPr/>
         </p:nvSpPr>
         <p:spPr>
           <a:xfrm rot="240000">
-            <a:off x="4141429" y="6828759"/>
+            <a:off x="1979353" y="6447759"/>
             <a:ext cx="2261616" cy="222250"/>
           </a:xfrm>
           <a:prstGeom prst="rect">

</xml_diff>

<commit_message>
Reasons slide 4: map caption names US universities under Iranian threat
Co-Authored-By: Claude Opus 5.5 <noreply@anthropic.com>
Claude-Session: https://claude.ai/code/session_01EUKBNPzc7y2DXSfnei23HU
</commit_message>
<xml_diff>
--- a/social/pptx/reasons-170m.pptx
+++ b/social/pptx/reasons-170m.pptx
@@ -5233,8 +5233,8 @@
         </p:nvSpPr>
         <p:spPr>
           <a:xfrm rot="-180000">
-            <a:off x="370103" y="3459040"/>
-            <a:ext cx="3962400" cy="260350"/>
+            <a:off x="370602" y="3478077"/>
+            <a:ext cx="3962400" cy="241300"/>
           </a:xfrm>
           <a:prstGeom prst="rect">
             <a:avLst/>
@@ -5248,12 +5248,12 @@
           <a:p>
             <a:pPr algn="ctr" indent="0" marL="0">
               <a:lnSpc>
-                <a:spcPts val="1800"/>
-              </a:lnSpc>
-              <a:buNone/>
-            </a:pPr>
-            <a:r>
-              <a:rPr lang="en-US" sz="1500" i="1" dirty="0">
+                <a:spcPts val="1680"/>
+              </a:lnSpc>
+              <a:buNone/>
+            </a:pPr>
+            <a:r>
+              <a:rPr lang="en-US" sz="1400" i="1" dirty="0">
                 <a:solidFill>
                   <a:srgbClr val="0A0A0A"/>
                 </a:solidFill>
@@ -5261,9 +5261,9 @@
                 <a:ea typeface="Noto Serif Display Light" pitchFamily="34" charset="-122"/>
                 <a:cs typeface="Noto Serif Display Light" pitchFamily="34" charset="-120"/>
               </a:rPr>
-              <a:t>Ближний Восток, весна 2026</a:t>
-            </a:r>
-            <a:endParaRPr lang="en-US" sz="1500" dirty="0"/>
+              <a:t>американские вузы под угрозой Ирана</a:t>
+            </a:r>
+            <a:endParaRPr lang="en-US" sz="1400" dirty="0"/>
           </a:p>
         </p:txBody>
       </p:sp>
@@ -5432,7 +5432,7 @@
         </p:nvSpPr>
         <p:spPr>
           <a:xfrm rot="-360000">
-            <a:off x="3810000" y="3429000"/>
+            <a:off x="3556000" y="2540000"/>
             <a:ext cx="584200" cy="584200"/>
           </a:xfrm>
           <a:prstGeom prst="ellipse">
@@ -5467,7 +5467,7 @@
         </p:blipFill>
         <p:spPr>
           <a:xfrm rot="-360000">
-            <a:off x="3956050" y="3575050"/>
+            <a:off x="3702050" y="2686050"/>
             <a:ext cx="292100" cy="292100"/>
           </a:xfrm>
           <a:prstGeom prst="rect">

</xml_diff>

<commit_message>
Reasons slide 7: text only; refresh zip, preview and PPTX
Co-Authored-By: Claude Opus 5.5 <noreply@anthropic.com>
Claude-Session: https://claude.ai/code/session_01EUKBNPzc7y2DXSfnei23HU
</commit_message>
<xml_diff>
--- a/social/pptx/reasons-170m.pptx
+++ b/social/pptx/reasons-170m.pptx
@@ -7556,7 +7556,7 @@
         </p:blipFill>
         <p:spPr>
           <a:xfrm>
-            <a:off x="3810000" y="1206500"/>
+            <a:off x="5842000" y="1016000"/>
             <a:ext cx="254000" cy="254000"/>
           </a:xfrm>
           <a:prstGeom prst="rect">
@@ -7580,7 +7580,7 @@
         </p:blipFill>
         <p:spPr>
           <a:xfrm>
-            <a:off x="4000500" y="5461000"/>
+            <a:off x="4826000" y="7493000"/>
             <a:ext cx="190500" cy="190500"/>
           </a:xfrm>
           <a:prstGeom prst="rect">
@@ -7596,8 +7596,8 @@
         </p:nvSpPr>
         <p:spPr>
           <a:xfrm>
-            <a:off x="457200" y="889000"/>
-            <a:ext cx="6300216" cy="673100"/>
+            <a:off x="457200" y="1460500"/>
+            <a:ext cx="6300216" cy="1301750"/>
           </a:xfrm>
           <a:prstGeom prst="rect">
             <a:avLst/>
@@ -7611,12 +7611,12 @@
           <a:p>
             <a:pPr algn="l" indent="0" marL="0">
               <a:lnSpc>
-                <a:spcPts val="4600"/>
-              </a:lnSpc>
-              <a:buNone/>
-            </a:pPr>
-            <a:r>
-              <a:rPr lang="en-US" sz="4600" b="1" spc="-160" kern="0" dirty="0">
+                <a:spcPts val="4800"/>
+              </a:lnSpc>
+              <a:buNone/>
+            </a:pPr>
+            <a:r>
+              <a:rPr lang="en-US" sz="4800" b="1" spc="-170" kern="0" dirty="0">
                 <a:solidFill>
                   <a:srgbClr val="0A0A0A"/>
                 </a:solidFill>
@@ -7628,12 +7628,12 @@
             </a:r>
             <a:pPr algn="l" indent="0" marL="0">
               <a:lnSpc>
-                <a:spcPts val="4600"/>
-              </a:lnSpc>
-              <a:buNone/>
-            </a:pPr>
-            <a:r>
-              <a:rPr lang="en-US" sz="5200" i="1" spc="-100" kern="0" dirty="0">
+                <a:spcPts val="4800"/>
+              </a:lnSpc>
+              <a:buNone/>
+            </a:pPr>
+            <a:r>
+              <a:rPr lang="en-US" sz="5400" i="1" spc="-110" kern="0" dirty="0">
                 <a:solidFill>
                   <a:srgbClr val="57068C"/>
                 </a:solidFill>
@@ -7643,7 +7643,7 @@
               </a:rPr>
               <a:t>сам</a:t>
             </a:r>
-            <a:endParaRPr lang="en-US" sz="4600" dirty="0"/>
+            <a:endParaRPr lang="en-US" sz="4800" dirty="0"/>
           </a:p>
         </p:txBody>
       </p:sp>
@@ -7655,8 +7655,8 @@
         </p:nvSpPr>
         <p:spPr>
           <a:xfrm>
-            <a:off x="457845" y="1675606"/>
-            <a:ext cx="6246368" cy="996950"/>
+            <a:off x="458391" y="2889151"/>
+            <a:ext cx="5620385" cy="1352550"/>
           </a:xfrm>
           <a:prstGeom prst="rect">
             <a:avLst/>
@@ -7670,12 +7670,12 @@
           <a:p>
             <a:pPr algn="l" indent="0" marL="0">
               <a:lnSpc>
-                <a:spcPts val="1960"/>
-              </a:lnSpc>
-              <a:buNone/>
-            </a:pPr>
-            <a:r>
-              <a:rPr lang="en-US" sz="1400" dirty="0">
+                <a:spcPts val="2130"/>
+              </a:lnSpc>
+              <a:buNone/>
+            </a:pPr>
+            <a:r>
+              <a:rPr lang="en-US" sz="1500" dirty="0">
                 <a:solidFill>
                   <a:srgbClr val="2B2A27"/>
                 </a:solidFill>
@@ -7685,7 +7685,7 @@
               </a:rPr>
               <a:t>В конце 12 класса я заметил простую вещь. Всё, чего я добился, я выучил сам: химию, математику, историю, SAT, IELTS, даже бодибилдинг. Я уверен, что могу научиться чему угодно. Поэтому для меня название университета было не главным.</a:t>
             </a:r>
-            <a:endParaRPr lang="en-US" sz="1400" dirty="0"/>
+            <a:endParaRPr lang="en-US" sz="1500" dirty="0"/>
           </a:p>
         </p:txBody>
       </p:sp>
@@ -7697,8 +7697,8 @@
         </p:nvSpPr>
         <p:spPr>
           <a:xfrm>
-            <a:off x="457845" y="2759869"/>
-            <a:ext cx="6246368" cy="996950"/>
+            <a:off x="458391" y="4369792"/>
+            <a:ext cx="5620385" cy="1079500"/>
           </a:xfrm>
           <a:prstGeom prst="rect">
             <a:avLst/>
@@ -7712,12 +7712,12 @@
           <a:p>
             <a:pPr algn="l" indent="0" marL="0">
               <a:lnSpc>
-                <a:spcPts val="1960"/>
-              </a:lnSpc>
-              <a:buNone/>
-            </a:pPr>
-            <a:r>
-              <a:rPr lang="en-US" sz="1400" dirty="0">
+                <a:spcPts val="2130"/>
+              </a:lnSpc>
+              <a:buNone/>
+            </a:pPr>
+            <a:r>
+              <a:rPr lang="en-US" sz="1500" dirty="0">
                 <a:solidFill>
                   <a:srgbClr val="2B2A27"/>
                 </a:solidFill>
@@ -7729,12 +7729,12 @@
             </a:r>
             <a:pPr algn="l" indent="0" marL="0">
               <a:lnSpc>
-                <a:spcPts val="1960"/>
-              </a:lnSpc>
-              <a:buNone/>
-            </a:pPr>
-            <a:r>
-              <a:rPr lang="en-US" sz="1400" b="1" dirty="0">
+                <a:spcPts val="2130"/>
+              </a:lnSpc>
+              <a:buNone/>
+            </a:pPr>
+            <a:r>
+              <a:rPr lang="en-US" sz="1500" b="1" dirty="0">
                 <a:solidFill>
                   <a:srgbClr val="0A0A0A"/>
                 </a:solidFill>
@@ -7746,12 +7746,12 @@
             </a:r>
             <a:pPr algn="l" indent="0" marL="0">
               <a:lnSpc>
-                <a:spcPts val="1960"/>
-              </a:lnSpc>
-              <a:buNone/>
-            </a:pPr>
-            <a:r>
-              <a:rPr lang="en-US" sz="1400" dirty="0">
+                <a:spcPts val="2130"/>
+              </a:lnSpc>
+              <a:buNone/>
+            </a:pPr>
+            <a:r>
+              <a:rPr lang="en-US" sz="1500" dirty="0">
                 <a:solidFill>
                   <a:srgbClr val="2B2A27"/>
                 </a:solidFill>
@@ -7761,7 +7761,7 @@
               </a:rPr>
               <a:t>.</a:t>
             </a:r>
-            <a:endParaRPr lang="en-US" sz="1400" dirty="0"/>
+            <a:endParaRPr lang="en-US" sz="1500" dirty="0"/>
           </a:p>
         </p:txBody>
       </p:sp>
@@ -7903,14 +7903,16 @@
         </p:nvSpPr>
         <p:spPr>
           <a:xfrm rot="-240000">
-            <a:off x="508000" y="4127500"/>
-            <a:ext cx="2984500" cy="3556000"/>
-          </a:xfrm>
-          <a:prstGeom prst="rect">
-            <a:avLst/>
+            <a:off x="457299" y="6413500"/>
+            <a:ext cx="1358900" cy="374650"/>
+          </a:xfrm>
+          <a:prstGeom prst="roundRect">
+            <a:avLst>
+              <a:gd name="adj" fmla="val 50000"/>
+            </a:avLst>
           </a:prstGeom>
           <a:solidFill>
-            <a:srgbClr val="FFFFFF"/>
+            <a:srgbClr val="57068C"/>
           </a:solidFill>
           <a:ln/>
           <a:effectLst>
@@ -7922,102 +7924,9 @@
           </a:effectLst>
         </p:spPr>
       </p:sp>
-      <p:sp>
-        <p:nvSpPr>
-          <p:cNvPr id="17" name="shape-16"/>
-          <p:cNvSpPr/>
-          <p:nvPr/>
-        </p:nvSpPr>
-        <p:spPr>
-          <a:xfrm rot="-420000">
-            <a:off x="1465245" y="4030169"/>
-            <a:ext cx="825500" cy="254000"/>
-          </a:xfrm>
-          <a:prstGeom prst="rect">
-            <a:avLst/>
-          </a:prstGeom>
-          <a:solidFill>
-            <a:srgbClr val="D5D5D4">
-              <a:alpha val="90000"/>
-            </a:srgbClr>
-          </a:solidFill>
-          <a:ln/>
-        </p:spPr>
-      </p:sp>
-      <p:sp>
-        <p:nvSpPr>
-          <p:cNvPr id="18" name="text-17"/>
-          <p:cNvSpPr txBox="1"/>
-          <p:nvPr/>
-        </p:nvSpPr>
-        <p:spPr>
-          <a:xfrm rot="-240000">
-            <a:off x="1035666" y="4000813"/>
-            <a:ext cx="2026031" cy="3556000"/>
-          </a:xfrm>
-          <a:prstGeom prst="rect">
-            <a:avLst/>
-          </a:prstGeom>
-          <a:noFill/>
-          <a:ln/>
-        </p:spPr>
-        <p:txBody>
-          <a:bodyPr wrap="square" lIns="0" tIns="0" rIns="0" bIns="0" rtlCol="0" anchor="t"/>
-          <a:lstStyle/>
-          <a:p>
-            <a:pPr algn="l" indent="0" marL="0">
-              <a:lnSpc>
-                <a:spcPts val="28000"/>
-              </a:lnSpc>
-              <a:buNone/>
-            </a:pPr>
-            <a:r>
-              <a:rPr lang="en-US" sz="28000" i="1" dirty="0">
-                <a:solidFill>
-                  <a:srgbClr val="0A0A0A"/>
-                </a:solidFill>
-                <a:latin typeface="Noto Serif Display Light" pitchFamily="34" charset="0"/>
-                <a:ea typeface="Noto Serif Display Light" pitchFamily="34" charset="-122"/>
-                <a:cs typeface="Noto Serif Display Light" pitchFamily="34" charset="-120"/>
-              </a:rPr>
-              <a:t>4</a:t>
-            </a:r>
-            <a:endParaRPr lang="en-US" sz="28000" dirty="0"/>
-          </a:p>
-        </p:txBody>
-      </p:sp>
-      <p:sp>
-        <p:nvSpPr>
-          <p:cNvPr id="19" name="shape-18"/>
-          <p:cNvSpPr/>
-          <p:nvPr/>
-        </p:nvSpPr>
-        <p:spPr>
-          <a:xfrm rot="300000">
-            <a:off x="5118001" y="5213350"/>
-            <a:ext cx="1358900" cy="374650"/>
-          </a:xfrm>
-          <a:prstGeom prst="roundRect">
-            <a:avLst>
-              <a:gd name="adj" fmla="val 50000"/>
-            </a:avLst>
-          </a:prstGeom>
-          <a:solidFill>
-            <a:srgbClr val="57068C"/>
-          </a:solidFill>
-          <a:ln/>
-          <a:effectLst>
-            <a:outerShdw sx="100000" sy="100000" kx="0" ky="0" algn="bl" rotWithShape="0" blurRad="177800" dist="76200" dir="5400000">
-              <a:srgbClr val="000000">
-                <a:alpha val="22000"/>
-              </a:srgbClr>
-            </a:outerShdw>
-          </a:effectLst>
-        </p:spPr>
-      </p:sp>
       <p:pic>
         <p:nvPicPr>
-          <p:cNvPr id="20" name="svg-19" descr="preencoded.png">    </p:cNvPr>
+          <p:cNvPr id="17" name="svg-16" descr="preencoded.png">    </p:cNvPr>
           <p:cNvPicPr>
             <a:picLocks noChangeAspect="1"/>
           </p:cNvPicPr>
@@ -8030,8 +7939,8 @@
           </a:stretch>
         </p:blipFill>
         <p:spPr>
-          <a:xfrm rot="300000">
-            <a:off x="5246666" y="5271365"/>
+          <a:xfrm rot="-240000">
+            <a:off x="585329" y="6544268"/>
             <a:ext cx="177800" cy="177800"/>
           </a:xfrm>
           <a:prstGeom prst="rect">
@@ -8041,13 +7950,13 @@
       </p:pic>
       <p:sp>
         <p:nvSpPr>
-          <p:cNvPr id="21" name="text-20"/>
+          <p:cNvPr id="18" name="text-17"/>
           <p:cNvSpPr txBox="1"/>
           <p:nvPr/>
         </p:nvSpPr>
         <p:spPr>
-          <a:xfrm rot="300000">
-            <a:off x="5498517" y="5300619"/>
+          <a:xfrm rot="-240000">
+            <a:off x="837990" y="6480841"/>
             <a:ext cx="901954" cy="222250"/>
           </a:xfrm>
           <a:prstGeom prst="rect">
@@ -8083,13 +7992,13 @@
       </p:sp>
       <p:sp>
         <p:nvSpPr>
-          <p:cNvPr id="22" name="shape-21"/>
+          <p:cNvPr id="19" name="shape-18"/>
           <p:cNvSpPr/>
           <p:nvPr/>
         </p:nvSpPr>
         <p:spPr>
-          <a:xfrm rot="-180000">
-            <a:off x="4916388" y="6076950"/>
+          <a:xfrm rot="180000">
+            <a:off x="2094012" y="6985000"/>
             <a:ext cx="1371600" cy="400050"/>
           </a:xfrm>
           <a:prstGeom prst="roundRect">
@@ -8117,7 +8026,7 @@
       </p:sp>
       <p:pic>
         <p:nvPicPr>
-          <p:cNvPr id="23" name="svg-22" descr="preencoded.png">    </p:cNvPr>
+          <p:cNvPr id="20" name="svg-19" descr="preencoded.png">    </p:cNvPr>
           <p:cNvPicPr>
             <a:picLocks noChangeAspect="1"/>
           </p:cNvPicPr>
@@ -8130,8 +8039,8 @@
           </a:stretch>
         </p:blipFill>
         <p:spPr>
-          <a:xfrm rot="-180000">
-            <a:off x="5058201" y="6211925"/>
+          <a:xfrm rot="180000">
+            <a:off x="2235824" y="7072275"/>
             <a:ext cx="177800" cy="177800"/>
           </a:xfrm>
           <a:prstGeom prst="rect">
@@ -8141,13 +8050,13 @@
       </p:pic>
       <p:sp>
         <p:nvSpPr>
-          <p:cNvPr id="24" name="text-23"/>
+          <p:cNvPr id="21" name="text-20"/>
           <p:cNvSpPr txBox="1"/>
           <p:nvPr/>
         </p:nvSpPr>
         <p:spPr>
-          <a:xfrm rot="-180000">
-            <a:off x="5309914" y="6159203"/>
+          <a:xfrm rot="180000">
+            <a:off x="2487538" y="7080546"/>
             <a:ext cx="888492" cy="222250"/>
           </a:xfrm>
           <a:prstGeom prst="rect">
@@ -8183,13 +8092,13 @@
       </p:sp>
       <p:sp>
         <p:nvSpPr>
-          <p:cNvPr id="25" name="text-24"/>
+          <p:cNvPr id="22" name="text-21"/>
           <p:cNvSpPr txBox="1"/>
           <p:nvPr/>
         </p:nvSpPr>
         <p:spPr>
           <a:xfrm rot="-240000">
-            <a:off x="4103384" y="6724848"/>
+            <a:off x="4103384" y="6540301"/>
             <a:ext cx="2248154" cy="768350"/>
           </a:xfrm>
           <a:prstGeom prst="rect">
@@ -8265,13 +8174,13 @@
       </p:sp>
       <p:sp>
         <p:nvSpPr>
-          <p:cNvPr id="26" name="shape-25"/>
+          <p:cNvPr id="23" name="shape-22"/>
           <p:cNvSpPr/>
           <p:nvPr/>
         </p:nvSpPr>
         <p:spPr>
           <a:xfrm rot="-360000">
-            <a:off x="2984500" y="4051300"/>
+            <a:off x="457200" y="825500"/>
             <a:ext cx="584200" cy="584200"/>
           </a:xfrm>
           <a:prstGeom prst="ellipse">
@@ -8292,7 +8201,7 @@
       </p:sp>
       <p:pic>
         <p:nvPicPr>
-          <p:cNvPr id="27" name="svg-26" descr="preencoded.png">    </p:cNvPr>
+          <p:cNvPr id="24" name="svg-23" descr="preencoded.png">    </p:cNvPr>
           <p:cNvPicPr>
             <a:picLocks noChangeAspect="1"/>
           </p:cNvPicPr>
@@ -8306,7 +8215,7 @@
         </p:blipFill>
         <p:spPr>
           <a:xfrm rot="-360000">
-            <a:off x="3130550" y="4197350"/>
+            <a:off x="603250" y="971550"/>
             <a:ext cx="292100" cy="292100"/>
           </a:xfrm>
           <a:prstGeom prst="rect">

</xml_diff>

<commit_message>
Reasons slide 2: group photo of Candidate Weekend participants instead of professor selfie
Co-Authored-By: Claude Opus 5.5 <noreply@anthropic.com>
Claude-Session: https://claude.ai/code/session_01EUKBNPzc7y2DXSfnei23HU
</commit_message>
<xml_diff>
--- a/social/pptx/reasons-170m.pptx
+++ b/social/pptx/reasons-170m.pptx
@@ -3065,7 +3065,7 @@
         <p:spPr>
           <a:xfrm rot="-180000">
             <a:off x="381000" y="952500"/>
-            <a:ext cx="3810000" cy="2641600"/>
+            <a:ext cx="3810000" cy="2895600"/>
           </a:xfrm>
           <a:prstGeom prst="rect">
             <a:avLst/>
@@ -3091,7 +3091,7 @@
         </p:nvSpPr>
         <p:spPr>
           <a:xfrm rot="-360000">
-            <a:off x="1805454" y="852675"/>
+            <a:off x="1798807" y="852849"/>
             <a:ext cx="825500" cy="254000"/>
           </a:xfrm>
           <a:prstGeom prst="rect">
@@ -3122,7 +3122,7 @@
         <p:spPr>
           <a:xfrm rot="-180000">
             <a:off x="475289" y="1054291"/>
-            <a:ext cx="3606800" cy="2159000"/>
+            <a:ext cx="3606800" cy="2413000"/>
           </a:xfrm>
           <a:prstGeom prst="rect">
             <a:avLst/>
@@ -3137,7 +3137,7 @@
         </p:nvSpPr>
         <p:spPr>
           <a:xfrm rot="-180000">
-            <a:off x="363124" y="3256023"/>
+            <a:off x="369771" y="3509849"/>
             <a:ext cx="3962400" cy="260350"/>
           </a:xfrm>
           <a:prstGeom prst="rect">
@@ -3165,7 +3165,7 @@
                 <a:ea typeface="Noto Serif Display Light" pitchFamily="34" charset="-122"/>
                 <a:cs typeface="Noto Serif Display Light" pitchFamily="34" charset="-120"/>
               </a:rPr>
-              <a:t>с профессором NYUAD</a:t>
+              <a:t>участники со всего мира</a:t>
             </a:r>
             <a:endParaRPr lang="en-US" sz="1500" dirty="0"/>
           </a:p>
@@ -3294,7 +3294,7 @@
         </p:nvSpPr>
         <p:spPr>
           <a:xfrm rot="-240000">
-            <a:off x="444649" y="3810000"/>
+            <a:off x="444649" y="4159250"/>
             <a:ext cx="2159000" cy="374650"/>
           </a:xfrm>
           <a:prstGeom prst="roundRect">
@@ -3331,7 +3331,7 @@
         </p:blipFill>
         <p:spPr>
           <a:xfrm rot="-240000">
-            <a:off x="573604" y="3968677"/>
+            <a:off x="573604" y="4317927"/>
             <a:ext cx="177800" cy="177800"/>
           </a:xfrm>
           <a:prstGeom prst="rect">
@@ -3347,7 +3347,7 @@
         </p:nvSpPr>
         <p:spPr>
           <a:xfrm rot="-240000">
-            <a:off x="825339" y="3877341"/>
+            <a:off x="825339" y="4226591"/>
             <a:ext cx="1750060" cy="222250"/>
           </a:xfrm>
           <a:prstGeom prst="rect">

</xml_diff>